<commit_message>
Sync full DP-800 Share pack for all training sessions.
Replace guide, SQL script, and Day 1-3 trainer slides so participants can follow the complete Data & AI France DP-800 course.

Co-authored-by: Cursor <cursoragent@cursor.com>
</commit_message>
<xml_diff>
--- a/DP-800/DP-800-Jour 1 - Session 1.pptx
+++ b/DP-800/DP-800-Jour 1 - Session 1.pptx
@@ -122,7 +122,7 @@
 <file path=ppt/revisionInfo.xml><?xml version="1.0" encoding="utf-8"?>
 <p1510:revInfo xmlns:a="http://schemas.openxmlformats.org/drawingml/2006/main" xmlns:r="http://schemas.openxmlformats.org/officeDocument/2006/relationships" xmlns:p1510="http://schemas.microsoft.com/office/powerpoint/2015/10/main">
   <p1510:revLst>
-    <p1510:client id="{C3DF1021-F882-41CB-AACB-35983D6A29C9}" v="3" dt="2026-07-28T13:31:12.975"/>
+    <p1510:client id="{C3DF1021-F882-41CB-AACB-35983D6A29C9}" v="6" dt="2026-07-29T16:15:29.529"/>
   </p1510:revLst>
 </p1510:revInfo>
 </file>
@@ -131,19 +131,27 @@
 <pc:chgInfo xmlns:a="http://schemas.openxmlformats.org/drawingml/2006/main" xmlns:r="http://schemas.openxmlformats.org/officeDocument/2006/relationships" xmlns:ac="http://schemas.microsoft.com/office/drawing/2013/main/command" xmlns:pc="http://schemas.microsoft.com/office/powerpoint/2013/main/command">
   <pc:docChgLst>
     <pc:chgData name="Rodrigue YENGO" userId="9019d928-c12d-48de-bdb2-52a833805ac2" providerId="ADAL" clId="{20734E0D-FF75-44B1-9DFF-D19DBB4D069A}"/>
-    <pc:docChg chg="undo custSel modSld modMainMaster">
-      <pc:chgData name="Rodrigue YENGO" userId="9019d928-c12d-48de-bdb2-52a833805ac2" providerId="ADAL" clId="{20734E0D-FF75-44B1-9DFF-D19DBB4D069A}" dt="2026-07-28T13:33:52.860" v="146" actId="14100"/>
+    <pc:docChg chg="undo custSel addSld delSld modSld modMainMaster">
+      <pc:chgData name="Rodrigue YENGO" userId="9019d928-c12d-48de-bdb2-52a833805ac2" providerId="ADAL" clId="{20734E0D-FF75-44B1-9DFF-D19DBB4D069A}" dt="2026-07-29T17:11:06.417" v="390" actId="22"/>
       <pc:docMkLst>
         <pc:docMk/>
       </pc:docMkLst>
-      <pc:sldChg chg="modSp mod">
-        <pc:chgData name="Rodrigue YENGO" userId="9019d928-c12d-48de-bdb2-52a833805ac2" providerId="ADAL" clId="{20734E0D-FF75-44B1-9DFF-D19DBB4D069A}" dt="2026-07-28T13:31:44.235" v="142" actId="27636"/>
+      <pc:sldChg chg="addSp delSp modSp mod">
+        <pc:chgData name="Rodrigue YENGO" userId="9019d928-c12d-48de-bdb2-52a833805ac2" providerId="ADAL" clId="{20734E0D-FF75-44B1-9DFF-D19DBB4D069A}" dt="2026-07-29T16:59:17.879" v="385" actId="21"/>
         <pc:sldMkLst>
           <pc:docMk/>
           <pc:sldMk cId="0" sldId="256"/>
         </pc:sldMkLst>
-        <pc:spChg chg="mod">
-          <ac:chgData name="Rodrigue YENGO" userId="9019d928-c12d-48de-bdb2-52a833805ac2" providerId="ADAL" clId="{20734E0D-FF75-44B1-9DFF-D19DBB4D069A}" dt="2026-07-28T13:31:44.235" v="142" actId="27636"/>
+        <pc:spChg chg="del">
+          <ac:chgData name="Rodrigue YENGO" userId="9019d928-c12d-48de-bdb2-52a833805ac2" providerId="ADAL" clId="{20734E0D-FF75-44B1-9DFF-D19DBB4D069A}" dt="2026-07-29T15:19:29.539" v="264" actId="478"/>
+          <ac:spMkLst>
+            <pc:docMk/>
+            <pc:sldMk cId="0" sldId="256"/>
+            <ac:spMk id="2" creationId="{00000000-0000-0000-0000-000000000000}"/>
+          </ac:spMkLst>
+        </pc:spChg>
+        <pc:spChg chg="del mod">
+          <ac:chgData name="Rodrigue YENGO" userId="9019d928-c12d-48de-bdb2-52a833805ac2" providerId="ADAL" clId="{20734E0D-FF75-44B1-9DFF-D19DBB4D069A}" dt="2026-07-29T15:20:12.070" v="286" actId="478"/>
           <ac:spMkLst>
             <pc:docMk/>
             <pc:sldMk cId="0" sldId="256"/>
@@ -151,7 +159,7 @@
           </ac:spMkLst>
         </pc:spChg>
         <pc:spChg chg="mod">
-          <ac:chgData name="Rodrigue YENGO" userId="9019d928-c12d-48de-bdb2-52a833805ac2" providerId="ADAL" clId="{20734E0D-FF75-44B1-9DFF-D19DBB4D069A}" dt="2026-07-28T13:31:44.235" v="142" actId="27636"/>
+          <ac:chgData name="Rodrigue YENGO" userId="9019d928-c12d-48de-bdb2-52a833805ac2" providerId="ADAL" clId="{20734E0D-FF75-44B1-9DFF-D19DBB4D069A}" dt="2026-07-29T15:19:10.779" v="263" actId="255"/>
           <ac:spMkLst>
             <pc:docMk/>
             <pc:sldMk cId="0" sldId="256"/>
@@ -159,15 +167,15 @@
           </ac:spMkLst>
         </pc:spChg>
         <pc:spChg chg="mod">
-          <ac:chgData name="Rodrigue YENGO" userId="9019d928-c12d-48de-bdb2-52a833805ac2" providerId="ADAL" clId="{20734E0D-FF75-44B1-9DFF-D19DBB4D069A}" dt="2026-07-28T13:31:44.235" v="142" actId="27636"/>
+          <ac:chgData name="Rodrigue YENGO" userId="9019d928-c12d-48de-bdb2-52a833805ac2" providerId="ADAL" clId="{20734E0D-FF75-44B1-9DFF-D19DBB4D069A}" dt="2026-07-29T15:18:53.299" v="259" actId="1035"/>
           <ac:spMkLst>
             <pc:docMk/>
             <pc:sldMk cId="0" sldId="256"/>
             <ac:spMk id="5" creationId="{00000000-0000-0000-0000-000000000000}"/>
           </ac:spMkLst>
         </pc:spChg>
-        <pc:spChg chg="mod">
-          <ac:chgData name="Rodrigue YENGO" userId="9019d928-c12d-48de-bdb2-52a833805ac2" providerId="ADAL" clId="{20734E0D-FF75-44B1-9DFF-D19DBB4D069A}" dt="2026-07-28T13:31:44.235" v="142" actId="27636"/>
+        <pc:spChg chg="del mod">
+          <ac:chgData name="Rodrigue YENGO" userId="9019d928-c12d-48de-bdb2-52a833805ac2" providerId="ADAL" clId="{20734E0D-FF75-44B1-9DFF-D19DBB4D069A}" dt="2026-07-29T15:20:12.070" v="286" actId="478"/>
           <ac:spMkLst>
             <pc:docMk/>
             <pc:sldMk cId="0" sldId="256"/>
@@ -175,30 +183,198 @@
           </ac:spMkLst>
         </pc:spChg>
         <pc:spChg chg="mod">
-          <ac:chgData name="Rodrigue YENGO" userId="9019d928-c12d-48de-bdb2-52a833805ac2" providerId="ADAL" clId="{20734E0D-FF75-44B1-9DFF-D19DBB4D069A}" dt="2026-07-28T13:31:44.235" v="142" actId="27636"/>
+          <ac:chgData name="Rodrigue YENGO" userId="9019d928-c12d-48de-bdb2-52a833805ac2" providerId="ADAL" clId="{20734E0D-FF75-44B1-9DFF-D19DBB4D069A}" dt="2026-07-29T10:52:03.198" v="159" actId="27636"/>
           <ac:spMkLst>
             <pc:docMk/>
             <pc:sldMk cId="0" sldId="256"/>
             <ac:spMk id="7" creationId="{00000000-0000-0000-0000-000000000000}"/>
           </ac:spMkLst>
         </pc:spChg>
-        <pc:spChg chg="mod">
-          <ac:chgData name="Rodrigue YENGO" userId="9019d928-c12d-48de-bdb2-52a833805ac2" providerId="ADAL" clId="{20734E0D-FF75-44B1-9DFF-D19DBB4D069A}" dt="2026-07-28T13:31:44.235" v="142" actId="27636"/>
+        <pc:spChg chg="del mod">
+          <ac:chgData name="Rodrigue YENGO" userId="9019d928-c12d-48de-bdb2-52a833805ac2" providerId="ADAL" clId="{20734E0D-FF75-44B1-9DFF-D19DBB4D069A}" dt="2026-07-29T15:20:12.070" v="286" actId="478"/>
           <ac:spMkLst>
             <pc:docMk/>
             <pc:sldMk cId="0" sldId="256"/>
             <ac:spMk id="8" creationId="{00000000-0000-0000-0000-000000000000}"/>
           </ac:spMkLst>
         </pc:spChg>
+        <pc:spChg chg="add">
+          <ac:chgData name="Rodrigue YENGO" userId="9019d928-c12d-48de-bdb2-52a833805ac2" providerId="ADAL" clId="{20734E0D-FF75-44B1-9DFF-D19DBB4D069A}" dt="2026-07-29T16:49:26.903" v="357" actId="11529"/>
+          <ac:spMkLst>
+            <pc:docMk/>
+            <pc:sldMk cId="0" sldId="256"/>
+            <ac:spMk id="9" creationId="{6F49019B-5F4D-555C-A52F-B88B715642CE}"/>
+          </ac:spMkLst>
+        </pc:spChg>
+        <pc:spChg chg="add del mod ord">
+          <ac:chgData name="Rodrigue YENGO" userId="9019d928-c12d-48de-bdb2-52a833805ac2" providerId="ADAL" clId="{20734E0D-FF75-44B1-9DFF-D19DBB4D069A}" dt="2026-07-29T16:57:55.066" v="371" actId="478"/>
+          <ac:spMkLst>
+            <pc:docMk/>
+            <pc:sldMk cId="0" sldId="256"/>
+            <ac:spMk id="10" creationId="{AABFA61D-5402-FF39-9524-3B6CC4F7AE76}"/>
+          </ac:spMkLst>
+        </pc:spChg>
+        <pc:spChg chg="add del">
+          <ac:chgData name="Rodrigue YENGO" userId="9019d928-c12d-48de-bdb2-52a833805ac2" providerId="ADAL" clId="{20734E0D-FF75-44B1-9DFF-D19DBB4D069A}" dt="2026-07-29T15:17:14.112" v="221" actId="478"/>
+          <ac:spMkLst>
+            <pc:docMk/>
+            <pc:sldMk cId="0" sldId="256"/>
+            <ac:spMk id="16" creationId="{767CA201-D5B7-4FCF-669D-3DFDC15D48E6}"/>
+          </ac:spMkLst>
+        </pc:spChg>
+        <pc:spChg chg="add del">
+          <ac:chgData name="Rodrigue YENGO" userId="9019d928-c12d-48de-bdb2-52a833805ac2" providerId="ADAL" clId="{20734E0D-FF75-44B1-9DFF-D19DBB4D069A}" dt="2026-07-29T15:17:14.112" v="221" actId="478"/>
+          <ac:spMkLst>
+            <pc:docMk/>
+            <pc:sldMk cId="0" sldId="256"/>
+            <ac:spMk id="18" creationId="{9B971DBD-B4FF-BB2C-1C20-6A4495793A2C}"/>
+          </ac:spMkLst>
+        </pc:spChg>
+        <pc:spChg chg="add del">
+          <ac:chgData name="Rodrigue YENGO" userId="9019d928-c12d-48de-bdb2-52a833805ac2" providerId="ADAL" clId="{20734E0D-FF75-44B1-9DFF-D19DBB4D069A}" dt="2026-07-29T15:17:16.705" v="223" actId="22"/>
+          <ac:spMkLst>
+            <pc:docMk/>
+            <pc:sldMk cId="0" sldId="256"/>
+            <ac:spMk id="20" creationId="{462D66F4-9B95-AE06-5EE8-D9253EF2019D}"/>
+          </ac:spMkLst>
+        </pc:spChg>
+        <pc:spChg chg="add del">
+          <ac:chgData name="Rodrigue YENGO" userId="9019d928-c12d-48de-bdb2-52a833805ac2" providerId="ADAL" clId="{20734E0D-FF75-44B1-9DFF-D19DBB4D069A}" dt="2026-07-29T15:17:16.705" v="223" actId="22"/>
+          <ac:spMkLst>
+            <pc:docMk/>
+            <pc:sldMk cId="0" sldId="256"/>
+            <ac:spMk id="22" creationId="{47D24792-5644-B750-2413-D659375731ED}"/>
+          </ac:spMkLst>
+        </pc:spChg>
+        <pc:spChg chg="add del">
+          <ac:chgData name="Rodrigue YENGO" userId="9019d928-c12d-48de-bdb2-52a833805ac2" providerId="ADAL" clId="{20734E0D-FF75-44B1-9DFF-D19DBB4D069A}" dt="2026-07-29T15:17:16.705" v="223" actId="22"/>
+          <ac:spMkLst>
+            <pc:docMk/>
+            <pc:sldMk cId="0" sldId="256"/>
+            <ac:spMk id="24" creationId="{E28E1E26-CF49-9ACC-24A9-BB0D8B91C264}"/>
+          </ac:spMkLst>
+        </pc:spChg>
+        <pc:spChg chg="mod">
+          <ac:chgData name="Rodrigue YENGO" userId="9019d928-c12d-48de-bdb2-52a833805ac2" providerId="ADAL" clId="{20734E0D-FF75-44B1-9DFF-D19DBB4D069A}" dt="2026-07-29T15:18:39.754" v="225" actId="207"/>
+          <ac:spMkLst>
+            <pc:docMk/>
+            <pc:sldMk cId="0" sldId="256"/>
+            <ac:spMk id="29" creationId="{BFAFCE9F-F655-DE5E-8623-A55D3352A71A}"/>
+          </ac:spMkLst>
+        </pc:spChg>
+        <pc:spChg chg="mod">
+          <ac:chgData name="Rodrigue YENGO" userId="9019d928-c12d-48de-bdb2-52a833805ac2" providerId="ADAL" clId="{20734E0D-FF75-44B1-9DFF-D19DBB4D069A}" dt="2026-07-29T15:18:39.754" v="225" actId="207"/>
+          <ac:spMkLst>
+            <pc:docMk/>
+            <pc:sldMk cId="0" sldId="256"/>
+            <ac:spMk id="30" creationId="{1D18B29D-19A7-958F-EDFF-28AB111EC413}"/>
+          </ac:spMkLst>
+        </pc:spChg>
+        <pc:grpChg chg="add mod">
+          <ac:chgData name="Rodrigue YENGO" userId="9019d928-c12d-48de-bdb2-52a833805ac2" providerId="ADAL" clId="{20734E0D-FF75-44B1-9DFF-D19DBB4D069A}" dt="2026-07-29T16:15:00.268" v="334" actId="1076"/>
+          <ac:grpSpMkLst>
+            <pc:docMk/>
+            <pc:sldMk cId="0" sldId="256"/>
+            <ac:grpSpMk id="25" creationId="{D3B55B10-A2FD-2E32-13F7-D0A2B472DE93}"/>
+          </ac:grpSpMkLst>
+        </pc:grpChg>
+        <pc:picChg chg="add del mod">
+          <ac:chgData name="Rodrigue YENGO" userId="9019d928-c12d-48de-bdb2-52a833805ac2" providerId="ADAL" clId="{20734E0D-FF75-44B1-9DFF-D19DBB4D069A}" dt="2026-07-29T16:49:09.837" v="353" actId="478"/>
+          <ac:picMkLst>
+            <pc:docMk/>
+            <pc:sldMk cId="0" sldId="256"/>
+            <ac:picMk id="3" creationId="{22732B3A-E372-5204-72AA-EADED9815306}"/>
+          </ac:picMkLst>
+        </pc:picChg>
+        <pc:picChg chg="add del mod">
+          <ac:chgData name="Rodrigue YENGO" userId="9019d928-c12d-48de-bdb2-52a833805ac2" providerId="ADAL" clId="{20734E0D-FF75-44B1-9DFF-D19DBB4D069A}" dt="2026-07-29T16:57:53.681" v="370" actId="478"/>
+          <ac:picMkLst>
+            <pc:docMk/>
+            <pc:sldMk cId="0" sldId="256"/>
+            <ac:picMk id="8" creationId="{12ABB541-79DD-5B3E-9E81-344E8DD98870}"/>
+          </ac:picMkLst>
+        </pc:picChg>
+        <pc:picChg chg="add del">
+          <ac:chgData name="Rodrigue YENGO" userId="9019d928-c12d-48de-bdb2-52a833805ac2" providerId="ADAL" clId="{20734E0D-FF75-44B1-9DFF-D19DBB4D069A}" dt="2026-07-29T15:17:14.112" v="221" actId="478"/>
+          <ac:picMkLst>
+            <pc:docMk/>
+            <pc:sldMk cId="0" sldId="256"/>
+            <ac:picMk id="10" creationId="{C47E1740-6F35-E1E9-DA25-E4BBBACEFB65}"/>
+          </ac:picMkLst>
+        </pc:picChg>
+        <pc:picChg chg="add del">
+          <ac:chgData name="Rodrigue YENGO" userId="9019d928-c12d-48de-bdb2-52a833805ac2" providerId="ADAL" clId="{20734E0D-FF75-44B1-9DFF-D19DBB4D069A}" dt="2026-07-29T15:17:14.112" v="221" actId="478"/>
+          <ac:picMkLst>
+            <pc:docMk/>
+            <pc:sldMk cId="0" sldId="256"/>
+            <ac:picMk id="12" creationId="{D9F870B4-F83A-1BD3-9AB1-7542DCFE75BF}"/>
+          </ac:picMkLst>
+        </pc:picChg>
+        <pc:picChg chg="add del">
+          <ac:chgData name="Rodrigue YENGO" userId="9019d928-c12d-48de-bdb2-52a833805ac2" providerId="ADAL" clId="{20734E0D-FF75-44B1-9DFF-D19DBB4D069A}" dt="2026-07-29T16:57:57.193" v="372" actId="478"/>
+          <ac:picMkLst>
+            <pc:docMk/>
+            <pc:sldMk cId="0" sldId="256"/>
+            <ac:picMk id="12" creationId="{E0BEF4B2-79ED-431F-E867-4878DD66B4BD}"/>
+          </ac:picMkLst>
+        </pc:picChg>
+        <pc:picChg chg="add del mod">
+          <ac:chgData name="Rodrigue YENGO" userId="9019d928-c12d-48de-bdb2-52a833805ac2" providerId="ADAL" clId="{20734E0D-FF75-44B1-9DFF-D19DBB4D069A}" dt="2026-07-29T16:59:17.879" v="385" actId="21"/>
+          <ac:picMkLst>
+            <pc:docMk/>
+            <pc:sldMk cId="0" sldId="256"/>
+            <ac:picMk id="14" creationId="{74641A68-2032-71B0-FD14-59BFCB457C2F}"/>
+          </ac:picMkLst>
+        </pc:picChg>
+        <pc:picChg chg="add del">
+          <ac:chgData name="Rodrigue YENGO" userId="9019d928-c12d-48de-bdb2-52a833805ac2" providerId="ADAL" clId="{20734E0D-FF75-44B1-9DFF-D19DBB4D069A}" dt="2026-07-29T15:17:14.112" v="221" actId="478"/>
+          <ac:picMkLst>
+            <pc:docMk/>
+            <pc:sldMk cId="0" sldId="256"/>
+            <ac:picMk id="14" creationId="{8DB74ABE-8236-5472-E1E0-39A703EA4BD9}"/>
+          </ac:picMkLst>
+        </pc:picChg>
+        <pc:picChg chg="mod">
+          <ac:chgData name="Rodrigue YENGO" userId="9019d928-c12d-48de-bdb2-52a833805ac2" providerId="ADAL" clId="{20734E0D-FF75-44B1-9DFF-D19DBB4D069A}" dt="2026-07-29T15:18:35.577" v="224"/>
+          <ac:picMkLst>
+            <pc:docMk/>
+            <pc:sldMk cId="0" sldId="256"/>
+            <ac:picMk id="26" creationId="{E66C4808-9747-E827-82F0-34C53DF93851}"/>
+          </ac:picMkLst>
+        </pc:picChg>
+        <pc:picChg chg="mod">
+          <ac:chgData name="Rodrigue YENGO" userId="9019d928-c12d-48de-bdb2-52a833805ac2" providerId="ADAL" clId="{20734E0D-FF75-44B1-9DFF-D19DBB4D069A}" dt="2026-07-29T15:18:35.577" v="224"/>
+          <ac:picMkLst>
+            <pc:docMk/>
+            <pc:sldMk cId="0" sldId="256"/>
+            <ac:picMk id="27" creationId="{D3E7D007-039A-92D6-43F9-F6C510974154}"/>
+          </ac:picMkLst>
+        </pc:picChg>
+        <pc:picChg chg="mod">
+          <ac:chgData name="Rodrigue YENGO" userId="9019d928-c12d-48de-bdb2-52a833805ac2" providerId="ADAL" clId="{20734E0D-FF75-44B1-9DFF-D19DBB4D069A}" dt="2026-07-29T15:18:35.577" v="224"/>
+          <ac:picMkLst>
+            <pc:docMk/>
+            <pc:sldMk cId="0" sldId="256"/>
+            <ac:picMk id="28" creationId="{F90629BD-61A3-18FF-A5F1-9A0EC7C03C14}"/>
+          </ac:picMkLst>
+        </pc:picChg>
       </pc:sldChg>
-      <pc:sldChg chg="modSp mod">
-        <pc:chgData name="Rodrigue YENGO" userId="9019d928-c12d-48de-bdb2-52a833805ac2" providerId="ADAL" clId="{20734E0D-FF75-44B1-9DFF-D19DBB4D069A}" dt="2026-07-28T13:31:44.235" v="142" actId="27636"/>
+      <pc:sldChg chg="delSp modSp mod">
+        <pc:chgData name="Rodrigue YENGO" userId="9019d928-c12d-48de-bdb2-52a833805ac2" providerId="ADAL" clId="{20734E0D-FF75-44B1-9DFF-D19DBB4D069A}" dt="2026-07-29T15:21:40.390" v="294" actId="255"/>
         <pc:sldMkLst>
           <pc:docMk/>
           <pc:sldMk cId="0" sldId="257"/>
         </pc:sldMkLst>
-        <pc:spChg chg="mod">
-          <ac:chgData name="Rodrigue YENGO" userId="9019d928-c12d-48de-bdb2-52a833805ac2" providerId="ADAL" clId="{20734E0D-FF75-44B1-9DFF-D19DBB4D069A}" dt="2026-07-28T13:31:44.235" v="142" actId="27636"/>
+        <pc:spChg chg="del mod">
+          <ac:chgData name="Rodrigue YENGO" userId="9019d928-c12d-48de-bdb2-52a833805ac2" providerId="ADAL" clId="{20734E0D-FF75-44B1-9DFF-D19DBB4D069A}" dt="2026-07-29T15:20:58.374" v="290" actId="478"/>
+          <ac:spMkLst>
+            <pc:docMk/>
+            <pc:sldMk cId="0" sldId="257"/>
+            <ac:spMk id="2" creationId="{00000000-0000-0000-0000-000000000000}"/>
+          </ac:spMkLst>
+        </pc:spChg>
+        <pc:spChg chg="del mod">
+          <ac:chgData name="Rodrigue YENGO" userId="9019d928-c12d-48de-bdb2-52a833805ac2" providerId="ADAL" clId="{20734E0D-FF75-44B1-9DFF-D19DBB4D069A}" dt="2026-07-29T15:21:01.534" v="291" actId="478"/>
           <ac:spMkLst>
             <pc:docMk/>
             <pc:sldMk cId="0" sldId="257"/>
@@ -206,7 +382,7 @@
           </ac:spMkLst>
         </pc:spChg>
         <pc:spChg chg="mod">
-          <ac:chgData name="Rodrigue YENGO" userId="9019d928-c12d-48de-bdb2-52a833805ac2" providerId="ADAL" clId="{20734E0D-FF75-44B1-9DFF-D19DBB4D069A}" dt="2026-07-28T13:31:44.235" v="142" actId="27636"/>
+          <ac:chgData name="Rodrigue YENGO" userId="9019d928-c12d-48de-bdb2-52a833805ac2" providerId="ADAL" clId="{20734E0D-FF75-44B1-9DFF-D19DBB4D069A}" dt="2026-07-29T10:52:03.220" v="170" actId="27636"/>
           <ac:spMkLst>
             <pc:docMk/>
             <pc:sldMk cId="0" sldId="257"/>
@@ -214,7 +390,15 @@
           </ac:spMkLst>
         </pc:spChg>
         <pc:spChg chg="mod">
-          <ac:chgData name="Rodrigue YENGO" userId="9019d928-c12d-48de-bdb2-52a833805ac2" providerId="ADAL" clId="{20734E0D-FF75-44B1-9DFF-D19DBB4D069A}" dt="2026-07-28T13:31:44.235" v="142" actId="27636"/>
+          <ac:chgData name="Rodrigue YENGO" userId="9019d928-c12d-48de-bdb2-52a833805ac2" providerId="ADAL" clId="{20734E0D-FF75-44B1-9DFF-D19DBB4D069A}" dt="2026-07-29T15:21:27.450" v="293" actId="255"/>
+          <ac:spMkLst>
+            <pc:docMk/>
+            <pc:sldMk cId="0" sldId="257"/>
+            <ac:spMk id="6" creationId="{00000000-0000-0000-0000-000000000000}"/>
+          </ac:spMkLst>
+        </pc:spChg>
+        <pc:spChg chg="mod">
+          <ac:chgData name="Rodrigue YENGO" userId="9019d928-c12d-48de-bdb2-52a833805ac2" providerId="ADAL" clId="{20734E0D-FF75-44B1-9DFF-D19DBB4D069A}" dt="2026-07-29T15:21:27.450" v="293" actId="255"/>
           <ac:spMkLst>
             <pc:docMk/>
             <pc:sldMk cId="0" sldId="257"/>
@@ -222,7 +406,15 @@
           </ac:spMkLst>
         </pc:spChg>
         <pc:spChg chg="mod">
-          <ac:chgData name="Rodrigue YENGO" userId="9019d928-c12d-48de-bdb2-52a833805ac2" providerId="ADAL" clId="{20734E0D-FF75-44B1-9DFF-D19DBB4D069A}" dt="2026-07-28T13:31:44.235" v="142" actId="27636"/>
+          <ac:chgData name="Rodrigue YENGO" userId="9019d928-c12d-48de-bdb2-52a833805ac2" providerId="ADAL" clId="{20734E0D-FF75-44B1-9DFF-D19DBB4D069A}" dt="2026-07-29T15:21:40.390" v="294" actId="255"/>
+          <ac:spMkLst>
+            <pc:docMk/>
+            <pc:sldMk cId="0" sldId="257"/>
+            <ac:spMk id="8" creationId="{00000000-0000-0000-0000-000000000000}"/>
+          </ac:spMkLst>
+        </pc:spChg>
+        <pc:spChg chg="mod">
+          <ac:chgData name="Rodrigue YENGO" userId="9019d928-c12d-48de-bdb2-52a833805ac2" providerId="ADAL" clId="{20734E0D-FF75-44B1-9DFF-D19DBB4D069A}" dt="2026-07-29T15:21:40.390" v="294" actId="255"/>
           <ac:spMkLst>
             <pc:docMk/>
             <pc:sldMk cId="0" sldId="257"/>
@@ -230,7 +422,15 @@
           </ac:spMkLst>
         </pc:spChg>
         <pc:spChg chg="mod">
-          <ac:chgData name="Rodrigue YENGO" userId="9019d928-c12d-48de-bdb2-52a833805ac2" providerId="ADAL" clId="{20734E0D-FF75-44B1-9DFF-D19DBB4D069A}" dt="2026-07-28T13:31:44.235" v="142" actId="27636"/>
+          <ac:chgData name="Rodrigue YENGO" userId="9019d928-c12d-48de-bdb2-52a833805ac2" providerId="ADAL" clId="{20734E0D-FF75-44B1-9DFF-D19DBB4D069A}" dt="2026-07-29T15:21:27.450" v="293" actId="255"/>
+          <ac:spMkLst>
+            <pc:docMk/>
+            <pc:sldMk cId="0" sldId="257"/>
+            <ac:spMk id="11" creationId="{00000000-0000-0000-0000-000000000000}"/>
+          </ac:spMkLst>
+        </pc:spChg>
+        <pc:spChg chg="mod">
+          <ac:chgData name="Rodrigue YENGO" userId="9019d928-c12d-48de-bdb2-52a833805ac2" providerId="ADAL" clId="{20734E0D-FF75-44B1-9DFF-D19DBB4D069A}" dt="2026-07-29T15:21:27.450" v="293" actId="255"/>
           <ac:spMkLst>
             <pc:docMk/>
             <pc:sldMk cId="0" sldId="257"/>
@@ -238,7 +438,15 @@
           </ac:spMkLst>
         </pc:spChg>
         <pc:spChg chg="mod">
-          <ac:chgData name="Rodrigue YENGO" userId="9019d928-c12d-48de-bdb2-52a833805ac2" providerId="ADAL" clId="{20734E0D-FF75-44B1-9DFF-D19DBB4D069A}" dt="2026-07-28T13:31:44.235" v="142" actId="27636"/>
+          <ac:chgData name="Rodrigue YENGO" userId="9019d928-c12d-48de-bdb2-52a833805ac2" providerId="ADAL" clId="{20734E0D-FF75-44B1-9DFF-D19DBB4D069A}" dt="2026-07-29T15:21:40.390" v="294" actId="255"/>
+          <ac:spMkLst>
+            <pc:docMk/>
+            <pc:sldMk cId="0" sldId="257"/>
+            <ac:spMk id="13" creationId="{00000000-0000-0000-0000-000000000000}"/>
+          </ac:spMkLst>
+        </pc:spChg>
+        <pc:spChg chg="mod">
+          <ac:chgData name="Rodrigue YENGO" userId="9019d928-c12d-48de-bdb2-52a833805ac2" providerId="ADAL" clId="{20734E0D-FF75-44B1-9DFF-D19DBB4D069A}" dt="2026-07-29T15:21:40.390" v="294" actId="255"/>
           <ac:spMkLst>
             <pc:docMk/>
             <pc:sldMk cId="0" sldId="257"/>
@@ -246,7 +454,15 @@
           </ac:spMkLst>
         </pc:spChg>
         <pc:spChg chg="mod">
-          <ac:chgData name="Rodrigue YENGO" userId="9019d928-c12d-48de-bdb2-52a833805ac2" providerId="ADAL" clId="{20734E0D-FF75-44B1-9DFF-D19DBB4D069A}" dt="2026-07-28T13:31:44.235" v="142" actId="27636"/>
+          <ac:chgData name="Rodrigue YENGO" userId="9019d928-c12d-48de-bdb2-52a833805ac2" providerId="ADAL" clId="{20734E0D-FF75-44B1-9DFF-D19DBB4D069A}" dt="2026-07-29T15:21:27.450" v="293" actId="255"/>
+          <ac:spMkLst>
+            <pc:docMk/>
+            <pc:sldMk cId="0" sldId="257"/>
+            <ac:spMk id="16" creationId="{00000000-0000-0000-0000-000000000000}"/>
+          </ac:spMkLst>
+        </pc:spChg>
+        <pc:spChg chg="mod">
+          <ac:chgData name="Rodrigue YENGO" userId="9019d928-c12d-48de-bdb2-52a833805ac2" providerId="ADAL" clId="{20734E0D-FF75-44B1-9DFF-D19DBB4D069A}" dt="2026-07-29T15:21:27.450" v="293" actId="255"/>
           <ac:spMkLst>
             <pc:docMk/>
             <pc:sldMk cId="0" sldId="257"/>
@@ -254,7 +470,15 @@
           </ac:spMkLst>
         </pc:spChg>
         <pc:spChg chg="mod">
-          <ac:chgData name="Rodrigue YENGO" userId="9019d928-c12d-48de-bdb2-52a833805ac2" providerId="ADAL" clId="{20734E0D-FF75-44B1-9DFF-D19DBB4D069A}" dt="2026-07-28T13:31:43.694" v="118" actId="27636"/>
+          <ac:chgData name="Rodrigue YENGO" userId="9019d928-c12d-48de-bdb2-52a833805ac2" providerId="ADAL" clId="{20734E0D-FF75-44B1-9DFF-D19DBB4D069A}" dt="2026-07-29T15:21:40.390" v="294" actId="255"/>
+          <ac:spMkLst>
+            <pc:docMk/>
+            <pc:sldMk cId="0" sldId="257"/>
+            <ac:spMk id="18" creationId="{00000000-0000-0000-0000-000000000000}"/>
+          </ac:spMkLst>
+        </pc:spChg>
+        <pc:spChg chg="mod">
+          <ac:chgData name="Rodrigue YENGO" userId="9019d928-c12d-48de-bdb2-52a833805ac2" providerId="ADAL" clId="{20734E0D-FF75-44B1-9DFF-D19DBB4D069A}" dt="2026-07-29T15:21:40.390" v="294" actId="255"/>
           <ac:spMkLst>
             <pc:docMk/>
             <pc:sldMk cId="0" sldId="257"/>
@@ -262,7 +486,15 @@
           </ac:spMkLst>
         </pc:spChg>
         <pc:spChg chg="mod">
-          <ac:chgData name="Rodrigue YENGO" userId="9019d928-c12d-48de-bdb2-52a833805ac2" providerId="ADAL" clId="{20734E0D-FF75-44B1-9DFF-D19DBB4D069A}" dt="2026-07-28T13:31:44.235" v="142" actId="27636"/>
+          <ac:chgData name="Rodrigue YENGO" userId="9019d928-c12d-48de-bdb2-52a833805ac2" providerId="ADAL" clId="{20734E0D-FF75-44B1-9DFF-D19DBB4D069A}" dt="2026-07-29T15:21:27.450" v="293" actId="255"/>
+          <ac:spMkLst>
+            <pc:docMk/>
+            <pc:sldMk cId="0" sldId="257"/>
+            <ac:spMk id="21" creationId="{00000000-0000-0000-0000-000000000000}"/>
+          </ac:spMkLst>
+        </pc:spChg>
+        <pc:spChg chg="mod">
+          <ac:chgData name="Rodrigue YENGO" userId="9019d928-c12d-48de-bdb2-52a833805ac2" providerId="ADAL" clId="{20734E0D-FF75-44B1-9DFF-D19DBB4D069A}" dt="2026-07-29T15:21:27.450" v="293" actId="255"/>
           <ac:spMkLst>
             <pc:docMk/>
             <pc:sldMk cId="0" sldId="257"/>
@@ -270,7 +502,15 @@
           </ac:spMkLst>
         </pc:spChg>
         <pc:spChg chg="mod">
-          <ac:chgData name="Rodrigue YENGO" userId="9019d928-c12d-48de-bdb2-52a833805ac2" providerId="ADAL" clId="{20734E0D-FF75-44B1-9DFF-D19DBB4D069A}" dt="2026-07-28T13:31:44.235" v="142" actId="27636"/>
+          <ac:chgData name="Rodrigue YENGO" userId="9019d928-c12d-48de-bdb2-52a833805ac2" providerId="ADAL" clId="{20734E0D-FF75-44B1-9DFF-D19DBB4D069A}" dt="2026-07-29T15:21:40.390" v="294" actId="255"/>
+          <ac:spMkLst>
+            <pc:docMk/>
+            <pc:sldMk cId="0" sldId="257"/>
+            <ac:spMk id="23" creationId="{00000000-0000-0000-0000-000000000000}"/>
+          </ac:spMkLst>
+        </pc:spChg>
+        <pc:spChg chg="mod">
+          <ac:chgData name="Rodrigue YENGO" userId="9019d928-c12d-48de-bdb2-52a833805ac2" providerId="ADAL" clId="{20734E0D-FF75-44B1-9DFF-D19DBB4D069A}" dt="2026-07-29T15:21:40.390" v="294" actId="255"/>
           <ac:spMkLst>
             <pc:docMk/>
             <pc:sldMk cId="0" sldId="257"/>
@@ -278,7 +518,15 @@
           </ac:spMkLst>
         </pc:spChg>
         <pc:spChg chg="mod">
-          <ac:chgData name="Rodrigue YENGO" userId="9019d928-c12d-48de-bdb2-52a833805ac2" providerId="ADAL" clId="{20734E0D-FF75-44B1-9DFF-D19DBB4D069A}" dt="2026-07-28T13:31:44.235" v="142" actId="27636"/>
+          <ac:chgData name="Rodrigue YENGO" userId="9019d928-c12d-48de-bdb2-52a833805ac2" providerId="ADAL" clId="{20734E0D-FF75-44B1-9DFF-D19DBB4D069A}" dt="2026-07-29T15:21:27.450" v="293" actId="255"/>
+          <ac:spMkLst>
+            <pc:docMk/>
+            <pc:sldMk cId="0" sldId="257"/>
+            <ac:spMk id="26" creationId="{00000000-0000-0000-0000-000000000000}"/>
+          </ac:spMkLst>
+        </pc:spChg>
+        <pc:spChg chg="mod">
+          <ac:chgData name="Rodrigue YENGO" userId="9019d928-c12d-48de-bdb2-52a833805ac2" providerId="ADAL" clId="{20734E0D-FF75-44B1-9DFF-D19DBB4D069A}" dt="2026-07-29T15:21:27.450" v="293" actId="255"/>
           <ac:spMkLst>
             <pc:docMk/>
             <pc:sldMk cId="0" sldId="257"/>
@@ -286,22 +534,46 @@
           </ac:spMkLst>
         </pc:spChg>
         <pc:spChg chg="mod">
-          <ac:chgData name="Rodrigue YENGO" userId="9019d928-c12d-48de-bdb2-52a833805ac2" providerId="ADAL" clId="{20734E0D-FF75-44B1-9DFF-D19DBB4D069A}" dt="2026-07-28T13:31:43.680" v="115" actId="27636"/>
+          <ac:chgData name="Rodrigue YENGO" userId="9019d928-c12d-48de-bdb2-52a833805ac2" providerId="ADAL" clId="{20734E0D-FF75-44B1-9DFF-D19DBB4D069A}" dt="2026-07-29T15:21:40.390" v="294" actId="255"/>
+          <ac:spMkLst>
+            <pc:docMk/>
+            <pc:sldMk cId="0" sldId="257"/>
+            <ac:spMk id="28" creationId="{00000000-0000-0000-0000-000000000000}"/>
+          </ac:spMkLst>
+        </pc:spChg>
+        <pc:spChg chg="mod">
+          <ac:chgData name="Rodrigue YENGO" userId="9019d928-c12d-48de-bdb2-52a833805ac2" providerId="ADAL" clId="{20734E0D-FF75-44B1-9DFF-D19DBB4D069A}" dt="2026-07-29T15:21:40.390" v="294" actId="255"/>
           <ac:spMkLst>
             <pc:docMk/>
             <pc:sldMk cId="0" sldId="257"/>
             <ac:spMk id="29" creationId="{00000000-0000-0000-0000-000000000000}"/>
           </ac:spMkLst>
         </pc:spChg>
+        <pc:picChg chg="del">
+          <ac:chgData name="Rodrigue YENGO" userId="9019d928-c12d-48de-bdb2-52a833805ac2" providerId="ADAL" clId="{20734E0D-FF75-44B1-9DFF-D19DBB4D069A}" dt="2026-07-29T15:21:04.461" v="292" actId="478"/>
+          <ac:picMkLst>
+            <pc:docMk/>
+            <pc:sldMk cId="0" sldId="257"/>
+            <ac:picMk id="30" creationId="{00000000-0000-0000-0000-000000000000}"/>
+          </ac:picMkLst>
+        </pc:picChg>
       </pc:sldChg>
-      <pc:sldChg chg="modSp mod">
-        <pc:chgData name="Rodrigue YENGO" userId="9019d928-c12d-48de-bdb2-52a833805ac2" providerId="ADAL" clId="{20734E0D-FF75-44B1-9DFF-D19DBB4D069A}" dt="2026-07-28T13:31:44.235" v="142" actId="27636"/>
+      <pc:sldChg chg="delSp modSp mod">
+        <pc:chgData name="Rodrigue YENGO" userId="9019d928-c12d-48de-bdb2-52a833805ac2" providerId="ADAL" clId="{20734E0D-FF75-44B1-9DFF-D19DBB4D069A}" dt="2026-07-29T15:21:57.631" v="297" actId="478"/>
         <pc:sldMkLst>
           <pc:docMk/>
           <pc:sldMk cId="0" sldId="258"/>
         </pc:sldMkLst>
-        <pc:spChg chg="mod">
-          <ac:chgData name="Rodrigue YENGO" userId="9019d928-c12d-48de-bdb2-52a833805ac2" providerId="ADAL" clId="{20734E0D-FF75-44B1-9DFF-D19DBB4D069A}" dt="2026-07-28T13:31:44.235" v="142" actId="27636"/>
+        <pc:spChg chg="del">
+          <ac:chgData name="Rodrigue YENGO" userId="9019d928-c12d-48de-bdb2-52a833805ac2" providerId="ADAL" clId="{20734E0D-FF75-44B1-9DFF-D19DBB4D069A}" dt="2026-07-29T15:21:51.967" v="295" actId="478"/>
+          <ac:spMkLst>
+            <pc:docMk/>
+            <pc:sldMk cId="0" sldId="258"/>
+            <ac:spMk id="2" creationId="{00000000-0000-0000-0000-000000000000}"/>
+          </ac:spMkLst>
+        </pc:spChg>
+        <pc:spChg chg="del mod">
+          <ac:chgData name="Rodrigue YENGO" userId="9019d928-c12d-48de-bdb2-52a833805ac2" providerId="ADAL" clId="{20734E0D-FF75-44B1-9DFF-D19DBB4D069A}" dt="2026-07-29T15:21:55.251" v="296" actId="478"/>
           <ac:spMkLst>
             <pc:docMk/>
             <pc:sldMk cId="0" sldId="258"/>
@@ -309,7 +581,7 @@
           </ac:spMkLst>
         </pc:spChg>
         <pc:spChg chg="mod">
-          <ac:chgData name="Rodrigue YENGO" userId="9019d928-c12d-48de-bdb2-52a833805ac2" providerId="ADAL" clId="{20734E0D-FF75-44B1-9DFF-D19DBB4D069A}" dt="2026-07-28T13:31:44.235" v="142" actId="27636"/>
+          <ac:chgData name="Rodrigue YENGO" userId="9019d928-c12d-48de-bdb2-52a833805ac2" providerId="ADAL" clId="{20734E0D-FF75-44B1-9DFF-D19DBB4D069A}" dt="2026-07-29T10:52:03.230" v="177" actId="27636"/>
           <ac:spMkLst>
             <pc:docMk/>
             <pc:sldMk cId="0" sldId="258"/>
@@ -317,7 +589,7 @@
           </ac:spMkLst>
         </pc:spChg>
         <pc:spChg chg="mod">
-          <ac:chgData name="Rodrigue YENGO" userId="9019d928-c12d-48de-bdb2-52a833805ac2" providerId="ADAL" clId="{20734E0D-FF75-44B1-9DFF-D19DBB4D069A}" dt="2026-07-28T13:31:44.235" v="142" actId="27636"/>
+          <ac:chgData name="Rodrigue YENGO" userId="9019d928-c12d-48de-bdb2-52a833805ac2" providerId="ADAL" clId="{20734E0D-FF75-44B1-9DFF-D19DBB4D069A}" dt="2026-07-29T10:52:03.227" v="175" actId="27636"/>
           <ac:spMkLst>
             <pc:docMk/>
             <pc:sldMk cId="0" sldId="258"/>
@@ -325,7 +597,7 @@
           </ac:spMkLst>
         </pc:spChg>
         <pc:spChg chg="mod">
-          <ac:chgData name="Rodrigue YENGO" userId="9019d928-c12d-48de-bdb2-52a833805ac2" providerId="ADAL" clId="{20734E0D-FF75-44B1-9DFF-D19DBB4D069A}" dt="2026-07-28T13:31:44.235" v="142" actId="27636"/>
+          <ac:chgData name="Rodrigue YENGO" userId="9019d928-c12d-48de-bdb2-52a833805ac2" providerId="ADAL" clId="{20734E0D-FF75-44B1-9DFF-D19DBB4D069A}" dt="2026-07-29T10:52:03.228" v="176" actId="27636"/>
           <ac:spMkLst>
             <pc:docMk/>
             <pc:sldMk cId="0" sldId="258"/>
@@ -333,7 +605,7 @@
           </ac:spMkLst>
         </pc:spChg>
         <pc:spChg chg="mod">
-          <ac:chgData name="Rodrigue YENGO" userId="9019d928-c12d-48de-bdb2-52a833805ac2" providerId="ADAL" clId="{20734E0D-FF75-44B1-9DFF-D19DBB4D069A}" dt="2026-07-28T13:31:44.235" v="142" actId="27636"/>
+          <ac:chgData name="Rodrigue YENGO" userId="9019d928-c12d-48de-bdb2-52a833805ac2" providerId="ADAL" clId="{20734E0D-FF75-44B1-9DFF-D19DBB4D069A}" dt="2026-07-29T10:52:03.226" v="174" actId="27636"/>
           <ac:spMkLst>
             <pc:docMk/>
             <pc:sldMk cId="0" sldId="258"/>
@@ -341,7 +613,7 @@
           </ac:spMkLst>
         </pc:spChg>
         <pc:spChg chg="mod">
-          <ac:chgData name="Rodrigue YENGO" userId="9019d928-c12d-48de-bdb2-52a833805ac2" providerId="ADAL" clId="{20734E0D-FF75-44B1-9DFF-D19DBB4D069A}" dt="2026-07-28T13:31:44.235" v="142" actId="27636"/>
+          <ac:chgData name="Rodrigue YENGO" userId="9019d928-c12d-48de-bdb2-52a833805ac2" providerId="ADAL" clId="{20734E0D-FF75-44B1-9DFF-D19DBB4D069A}" dt="2026-07-29T10:52:03.231" v="178" actId="27636"/>
           <ac:spMkLst>
             <pc:docMk/>
             <pc:sldMk cId="0" sldId="258"/>
@@ -349,22 +621,38 @@
           </ac:spMkLst>
         </pc:spChg>
         <pc:spChg chg="mod">
-          <ac:chgData name="Rodrigue YENGO" userId="9019d928-c12d-48de-bdb2-52a833805ac2" providerId="ADAL" clId="{20734E0D-FF75-44B1-9DFF-D19DBB4D069A}" dt="2026-07-28T13:31:44.235" v="142" actId="27636"/>
+          <ac:chgData name="Rodrigue YENGO" userId="9019d928-c12d-48de-bdb2-52a833805ac2" providerId="ADAL" clId="{20734E0D-FF75-44B1-9DFF-D19DBB4D069A}" dt="2026-07-29T10:52:03.224" v="172" actId="27636"/>
           <ac:spMkLst>
             <pc:docMk/>
             <pc:sldMk cId="0" sldId="258"/>
             <ac:spMk id="12" creationId="{00000000-0000-0000-0000-000000000000}"/>
           </ac:spMkLst>
         </pc:spChg>
+        <pc:picChg chg="del">
+          <ac:chgData name="Rodrigue YENGO" userId="9019d928-c12d-48de-bdb2-52a833805ac2" providerId="ADAL" clId="{20734E0D-FF75-44B1-9DFF-D19DBB4D069A}" dt="2026-07-29T15:21:57.631" v="297" actId="478"/>
+          <ac:picMkLst>
+            <pc:docMk/>
+            <pc:sldMk cId="0" sldId="258"/>
+            <ac:picMk id="14" creationId="{00000000-0000-0000-0000-000000000000}"/>
+          </ac:picMkLst>
+        </pc:picChg>
       </pc:sldChg>
-      <pc:sldChg chg="modSp mod">
-        <pc:chgData name="Rodrigue YENGO" userId="9019d928-c12d-48de-bdb2-52a833805ac2" providerId="ADAL" clId="{20734E0D-FF75-44B1-9DFF-D19DBB4D069A}" dt="2026-07-28T13:31:44.235" v="142" actId="27636"/>
+      <pc:sldChg chg="delSp modSp mod">
+        <pc:chgData name="Rodrigue YENGO" userId="9019d928-c12d-48de-bdb2-52a833805ac2" providerId="ADAL" clId="{20734E0D-FF75-44B1-9DFF-D19DBB4D069A}" dt="2026-07-29T15:22:42.077" v="303" actId="478"/>
         <pc:sldMkLst>
           <pc:docMk/>
           <pc:sldMk cId="0" sldId="259"/>
         </pc:sldMkLst>
-        <pc:spChg chg="mod">
-          <ac:chgData name="Rodrigue YENGO" userId="9019d928-c12d-48de-bdb2-52a833805ac2" providerId="ADAL" clId="{20734E0D-FF75-44B1-9DFF-D19DBB4D069A}" dt="2026-07-28T13:31:44.235" v="142" actId="27636"/>
+        <pc:spChg chg="del">
+          <ac:chgData name="Rodrigue YENGO" userId="9019d928-c12d-48de-bdb2-52a833805ac2" providerId="ADAL" clId="{20734E0D-FF75-44B1-9DFF-D19DBB4D069A}" dt="2026-07-29T15:22:24.540" v="301" actId="478"/>
+          <ac:spMkLst>
+            <pc:docMk/>
+            <pc:sldMk cId="0" sldId="259"/>
+            <ac:spMk id="2" creationId="{00000000-0000-0000-0000-000000000000}"/>
+          </ac:spMkLst>
+        </pc:spChg>
+        <pc:spChg chg="del mod">
+          <ac:chgData name="Rodrigue YENGO" userId="9019d928-c12d-48de-bdb2-52a833805ac2" providerId="ADAL" clId="{20734E0D-FF75-44B1-9DFF-D19DBB4D069A}" dt="2026-07-29T15:22:42.077" v="303" actId="478"/>
           <ac:spMkLst>
             <pc:docMk/>
             <pc:sldMk cId="0" sldId="259"/>
@@ -372,7 +660,7 @@
           </ac:spMkLst>
         </pc:spChg>
         <pc:spChg chg="mod">
-          <ac:chgData name="Rodrigue YENGO" userId="9019d928-c12d-48de-bdb2-52a833805ac2" providerId="ADAL" clId="{20734E0D-FF75-44B1-9DFF-D19DBB4D069A}" dt="2026-07-28T13:31:44.235" v="142" actId="27636"/>
+          <ac:chgData name="Rodrigue YENGO" userId="9019d928-c12d-48de-bdb2-52a833805ac2" providerId="ADAL" clId="{20734E0D-FF75-44B1-9DFF-D19DBB4D069A}" dt="2026-07-29T10:52:03.235" v="180" actId="27636"/>
           <ac:spMkLst>
             <pc:docMk/>
             <pc:sldMk cId="0" sldId="259"/>
@@ -380,7 +668,7 @@
           </ac:spMkLst>
         </pc:spChg>
         <pc:spChg chg="mod">
-          <ac:chgData name="Rodrigue YENGO" userId="9019d928-c12d-48de-bdb2-52a833805ac2" providerId="ADAL" clId="{20734E0D-FF75-44B1-9DFF-D19DBB4D069A}" dt="2026-07-28T13:31:44.235" v="142" actId="27636"/>
+          <ac:chgData name="Rodrigue YENGO" userId="9019d928-c12d-48de-bdb2-52a833805ac2" providerId="ADAL" clId="{20734E0D-FF75-44B1-9DFF-D19DBB4D069A}" dt="2026-07-29T10:52:03.233" v="179" actId="27636"/>
           <ac:spMkLst>
             <pc:docMk/>
             <pc:sldMk cId="0" sldId="259"/>
@@ -388,7 +676,7 @@
           </ac:spMkLst>
         </pc:spChg>
         <pc:spChg chg="mod">
-          <ac:chgData name="Rodrigue YENGO" userId="9019d928-c12d-48de-bdb2-52a833805ac2" providerId="ADAL" clId="{20734E0D-FF75-44B1-9DFF-D19DBB4D069A}" dt="2026-07-28T13:31:44.235" v="142" actId="27636"/>
+          <ac:chgData name="Rodrigue YENGO" userId="9019d928-c12d-48de-bdb2-52a833805ac2" providerId="ADAL" clId="{20734E0D-FF75-44B1-9DFF-D19DBB4D069A}" dt="2026-07-29T10:52:03.238" v="182" actId="27636"/>
           <ac:spMkLst>
             <pc:docMk/>
             <pc:sldMk cId="0" sldId="259"/>
@@ -396,7 +684,7 @@
           </ac:spMkLst>
         </pc:spChg>
         <pc:spChg chg="mod">
-          <ac:chgData name="Rodrigue YENGO" userId="9019d928-c12d-48de-bdb2-52a833805ac2" providerId="ADAL" clId="{20734E0D-FF75-44B1-9DFF-D19DBB4D069A}" dt="2026-07-28T13:31:44.235" v="142" actId="27636"/>
+          <ac:chgData name="Rodrigue YENGO" userId="9019d928-c12d-48de-bdb2-52a833805ac2" providerId="ADAL" clId="{20734E0D-FF75-44B1-9DFF-D19DBB4D069A}" dt="2026-07-29T10:52:03.240" v="183" actId="27636"/>
           <ac:spMkLst>
             <pc:docMk/>
             <pc:sldMk cId="0" sldId="259"/>
@@ -404,22 +692,38 @@
           </ac:spMkLst>
         </pc:spChg>
         <pc:spChg chg="mod">
-          <ac:chgData name="Rodrigue YENGO" userId="9019d928-c12d-48de-bdb2-52a833805ac2" providerId="ADAL" clId="{20734E0D-FF75-44B1-9DFF-D19DBB4D069A}" dt="2026-07-28T13:31:44.235" v="142" actId="27636"/>
+          <ac:chgData name="Rodrigue YENGO" userId="9019d928-c12d-48de-bdb2-52a833805ac2" providerId="ADAL" clId="{20734E0D-FF75-44B1-9DFF-D19DBB4D069A}" dt="2026-07-29T10:52:03.241" v="184" actId="27636"/>
           <ac:spMkLst>
             <pc:docMk/>
             <pc:sldMk cId="0" sldId="259"/>
             <ac:spMk id="11" creationId="{00000000-0000-0000-0000-000000000000}"/>
           </ac:spMkLst>
         </pc:spChg>
+        <pc:picChg chg="del">
+          <ac:chgData name="Rodrigue YENGO" userId="9019d928-c12d-48de-bdb2-52a833805ac2" providerId="ADAL" clId="{20734E0D-FF75-44B1-9DFF-D19DBB4D069A}" dt="2026-07-29T15:22:39.121" v="302" actId="478"/>
+          <ac:picMkLst>
+            <pc:docMk/>
+            <pc:sldMk cId="0" sldId="259"/>
+            <ac:picMk id="13" creationId="{00000000-0000-0000-0000-000000000000}"/>
+          </ac:picMkLst>
+        </pc:picChg>
       </pc:sldChg>
-      <pc:sldChg chg="modSp mod">
-        <pc:chgData name="Rodrigue YENGO" userId="9019d928-c12d-48de-bdb2-52a833805ac2" providerId="ADAL" clId="{20734E0D-FF75-44B1-9DFF-D19DBB4D069A}" dt="2026-07-28T13:31:44.235" v="142" actId="27636"/>
+      <pc:sldChg chg="delSp modSp mod">
+        <pc:chgData name="Rodrigue YENGO" userId="9019d928-c12d-48de-bdb2-52a833805ac2" providerId="ADAL" clId="{20734E0D-FF75-44B1-9DFF-D19DBB4D069A}" dt="2026-07-29T15:22:49.725" v="306" actId="478"/>
         <pc:sldMkLst>
           <pc:docMk/>
           <pc:sldMk cId="0" sldId="260"/>
         </pc:sldMkLst>
-        <pc:spChg chg="mod">
-          <ac:chgData name="Rodrigue YENGO" userId="9019d928-c12d-48de-bdb2-52a833805ac2" providerId="ADAL" clId="{20734E0D-FF75-44B1-9DFF-D19DBB4D069A}" dt="2026-07-28T13:31:44.235" v="142" actId="27636"/>
+        <pc:spChg chg="del">
+          <ac:chgData name="Rodrigue YENGO" userId="9019d928-c12d-48de-bdb2-52a833805ac2" providerId="ADAL" clId="{20734E0D-FF75-44B1-9DFF-D19DBB4D069A}" dt="2026-07-29T15:22:45.280" v="304" actId="478"/>
+          <ac:spMkLst>
+            <pc:docMk/>
+            <pc:sldMk cId="0" sldId="260"/>
+            <ac:spMk id="2" creationId="{00000000-0000-0000-0000-000000000000}"/>
+          </ac:spMkLst>
+        </pc:spChg>
+        <pc:spChg chg="del mod">
+          <ac:chgData name="Rodrigue YENGO" userId="9019d928-c12d-48de-bdb2-52a833805ac2" providerId="ADAL" clId="{20734E0D-FF75-44B1-9DFF-D19DBB4D069A}" dt="2026-07-29T15:22:47.171" v="305" actId="478"/>
           <ac:spMkLst>
             <pc:docMk/>
             <pc:sldMk cId="0" sldId="260"/>
@@ -427,7 +731,7 @@
           </ac:spMkLst>
         </pc:spChg>
         <pc:spChg chg="mod">
-          <ac:chgData name="Rodrigue YENGO" userId="9019d928-c12d-48de-bdb2-52a833805ac2" providerId="ADAL" clId="{20734E0D-FF75-44B1-9DFF-D19DBB4D069A}" dt="2026-07-28T13:31:44.235" v="142" actId="27636"/>
+          <ac:chgData name="Rodrigue YENGO" userId="9019d928-c12d-48de-bdb2-52a833805ac2" providerId="ADAL" clId="{20734E0D-FF75-44B1-9DFF-D19DBB4D069A}" dt="2026-07-29T10:52:03.249" v="187" actId="27636"/>
           <ac:spMkLst>
             <pc:docMk/>
             <pc:sldMk cId="0" sldId="260"/>
@@ -435,22 +739,38 @@
           </ac:spMkLst>
         </pc:spChg>
         <pc:spChg chg="mod">
-          <ac:chgData name="Rodrigue YENGO" userId="9019d928-c12d-48de-bdb2-52a833805ac2" providerId="ADAL" clId="{20734E0D-FF75-44B1-9DFF-D19DBB4D069A}" dt="2026-07-28T13:31:44.235" v="142" actId="27636"/>
+          <ac:chgData name="Rodrigue YENGO" userId="9019d928-c12d-48de-bdb2-52a833805ac2" providerId="ADAL" clId="{20734E0D-FF75-44B1-9DFF-D19DBB4D069A}" dt="2026-07-29T10:52:03.246" v="185" actId="27636"/>
           <ac:spMkLst>
             <pc:docMk/>
             <pc:sldMk cId="0" sldId="260"/>
             <ac:spMk id="7" creationId="{00000000-0000-0000-0000-000000000000}"/>
           </ac:spMkLst>
         </pc:spChg>
+        <pc:picChg chg="del">
+          <ac:chgData name="Rodrigue YENGO" userId="9019d928-c12d-48de-bdb2-52a833805ac2" providerId="ADAL" clId="{20734E0D-FF75-44B1-9DFF-D19DBB4D069A}" dt="2026-07-29T15:22:49.725" v="306" actId="478"/>
+          <ac:picMkLst>
+            <pc:docMk/>
+            <pc:sldMk cId="0" sldId="260"/>
+            <ac:picMk id="8" creationId="{00000000-0000-0000-0000-000000000000}"/>
+          </ac:picMkLst>
+        </pc:picChg>
       </pc:sldChg>
-      <pc:sldChg chg="modSp mod">
-        <pc:chgData name="Rodrigue YENGO" userId="9019d928-c12d-48de-bdb2-52a833805ac2" providerId="ADAL" clId="{20734E0D-FF75-44B1-9DFF-D19DBB4D069A}" dt="2026-07-28T13:31:44.235" v="142" actId="27636"/>
+      <pc:sldChg chg="delSp modSp mod">
+        <pc:chgData name="Rodrigue YENGO" userId="9019d928-c12d-48de-bdb2-52a833805ac2" providerId="ADAL" clId="{20734E0D-FF75-44B1-9DFF-D19DBB4D069A}" dt="2026-07-29T15:22:57.391" v="309" actId="478"/>
         <pc:sldMkLst>
           <pc:docMk/>
           <pc:sldMk cId="0" sldId="261"/>
         </pc:sldMkLst>
+        <pc:spChg chg="del mod">
+          <ac:chgData name="Rodrigue YENGO" userId="9019d928-c12d-48de-bdb2-52a833805ac2" providerId="ADAL" clId="{20734E0D-FF75-44B1-9DFF-D19DBB4D069A}" dt="2026-07-29T15:22:54.472" v="308" actId="478"/>
+          <ac:spMkLst>
+            <pc:docMk/>
+            <pc:sldMk cId="0" sldId="261"/>
+            <ac:spMk id="2" creationId="{00000000-0000-0000-0000-000000000000}"/>
+          </ac:spMkLst>
+        </pc:spChg>
         <pc:spChg chg="mod">
-          <ac:chgData name="Rodrigue YENGO" userId="9019d928-c12d-48de-bdb2-52a833805ac2" providerId="ADAL" clId="{20734E0D-FF75-44B1-9DFF-D19DBB4D069A}" dt="2026-07-28T13:31:44.235" v="142" actId="27636"/>
+          <ac:chgData name="Rodrigue YENGO" userId="9019d928-c12d-48de-bdb2-52a833805ac2" providerId="ADAL" clId="{20734E0D-FF75-44B1-9DFF-D19DBB4D069A}" dt="2026-07-29T10:52:03.252" v="188" actId="27636"/>
           <ac:spMkLst>
             <pc:docMk/>
             <pc:sldMk cId="0" sldId="261"/>
@@ -458,7 +778,7 @@
           </ac:spMkLst>
         </pc:spChg>
         <pc:spChg chg="mod">
-          <ac:chgData name="Rodrigue YENGO" userId="9019d928-c12d-48de-bdb2-52a833805ac2" providerId="ADAL" clId="{20734E0D-FF75-44B1-9DFF-D19DBB4D069A}" dt="2026-07-28T13:31:44.235" v="142" actId="27636"/>
+          <ac:chgData name="Rodrigue YENGO" userId="9019d928-c12d-48de-bdb2-52a833805ac2" providerId="ADAL" clId="{20734E0D-FF75-44B1-9DFF-D19DBB4D069A}" dt="2026-07-29T10:52:03.254" v="189" actId="27636"/>
           <ac:spMkLst>
             <pc:docMk/>
             <pc:sldMk cId="0" sldId="261"/>
@@ -466,22 +786,38 @@
           </ac:spMkLst>
         </pc:spChg>
         <pc:spChg chg="mod">
-          <ac:chgData name="Rodrigue YENGO" userId="9019d928-c12d-48de-bdb2-52a833805ac2" providerId="ADAL" clId="{20734E0D-FF75-44B1-9DFF-D19DBB4D069A}" dt="2026-07-28T13:31:44.235" v="142" actId="27636"/>
+          <ac:chgData name="Rodrigue YENGO" userId="9019d928-c12d-48de-bdb2-52a833805ac2" providerId="ADAL" clId="{20734E0D-FF75-44B1-9DFF-D19DBB4D069A}" dt="2026-07-29T10:52:03.255" v="190" actId="27636"/>
           <ac:spMkLst>
             <pc:docMk/>
             <pc:sldMk cId="0" sldId="261"/>
             <ac:spMk id="5" creationId="{00000000-0000-0000-0000-000000000000}"/>
           </ac:spMkLst>
         </pc:spChg>
+        <pc:picChg chg="del">
+          <ac:chgData name="Rodrigue YENGO" userId="9019d928-c12d-48de-bdb2-52a833805ac2" providerId="ADAL" clId="{20734E0D-FF75-44B1-9DFF-D19DBB4D069A}" dt="2026-07-29T15:22:57.391" v="309" actId="478"/>
+          <ac:picMkLst>
+            <pc:docMk/>
+            <pc:sldMk cId="0" sldId="261"/>
+            <ac:picMk id="14" creationId="{00000000-0000-0000-0000-000000000000}"/>
+          </ac:picMkLst>
+        </pc:picChg>
       </pc:sldChg>
-      <pc:sldChg chg="modSp mod">
-        <pc:chgData name="Rodrigue YENGO" userId="9019d928-c12d-48de-bdb2-52a833805ac2" providerId="ADAL" clId="{20734E0D-FF75-44B1-9DFF-D19DBB4D069A}" dt="2026-07-28T13:31:44.235" v="142" actId="27636"/>
+      <pc:sldChg chg="delSp modSp mod">
+        <pc:chgData name="Rodrigue YENGO" userId="9019d928-c12d-48de-bdb2-52a833805ac2" providerId="ADAL" clId="{20734E0D-FF75-44B1-9DFF-D19DBB4D069A}" dt="2026-07-29T15:23:06.027" v="312" actId="478"/>
         <pc:sldMkLst>
           <pc:docMk/>
           <pc:sldMk cId="0" sldId="262"/>
         </pc:sldMkLst>
-        <pc:spChg chg="mod">
-          <ac:chgData name="Rodrigue YENGO" userId="9019d928-c12d-48de-bdb2-52a833805ac2" providerId="ADAL" clId="{20734E0D-FF75-44B1-9DFF-D19DBB4D069A}" dt="2026-07-28T13:31:44.235" v="142" actId="27636"/>
+        <pc:spChg chg="del">
+          <ac:chgData name="Rodrigue YENGO" userId="9019d928-c12d-48de-bdb2-52a833805ac2" providerId="ADAL" clId="{20734E0D-FF75-44B1-9DFF-D19DBB4D069A}" dt="2026-07-29T15:23:00.868" v="310" actId="478"/>
+          <ac:spMkLst>
+            <pc:docMk/>
+            <pc:sldMk cId="0" sldId="262"/>
+            <ac:spMk id="2" creationId="{00000000-0000-0000-0000-000000000000}"/>
+          </ac:spMkLst>
+        </pc:spChg>
+        <pc:spChg chg="del mod">
+          <ac:chgData name="Rodrigue YENGO" userId="9019d928-c12d-48de-bdb2-52a833805ac2" providerId="ADAL" clId="{20734E0D-FF75-44B1-9DFF-D19DBB4D069A}" dt="2026-07-29T15:23:03.486" v="311" actId="478"/>
           <ac:spMkLst>
             <pc:docMk/>
             <pc:sldMk cId="0" sldId="262"/>
@@ -489,22 +825,38 @@
           </ac:spMkLst>
         </pc:spChg>
         <pc:spChg chg="mod">
-          <ac:chgData name="Rodrigue YENGO" userId="9019d928-c12d-48de-bdb2-52a833805ac2" providerId="ADAL" clId="{20734E0D-FF75-44B1-9DFF-D19DBB4D069A}" dt="2026-07-28T13:31:44.235" v="142" actId="27636"/>
+          <ac:chgData name="Rodrigue YENGO" userId="9019d928-c12d-48de-bdb2-52a833805ac2" providerId="ADAL" clId="{20734E0D-FF75-44B1-9DFF-D19DBB4D069A}" dt="2026-07-29T10:52:03.260" v="192" actId="27636"/>
           <ac:spMkLst>
             <pc:docMk/>
             <pc:sldMk cId="0" sldId="262"/>
             <ac:spMk id="4" creationId="{00000000-0000-0000-0000-000000000000}"/>
           </ac:spMkLst>
         </pc:spChg>
+        <pc:picChg chg="del">
+          <ac:chgData name="Rodrigue YENGO" userId="9019d928-c12d-48de-bdb2-52a833805ac2" providerId="ADAL" clId="{20734E0D-FF75-44B1-9DFF-D19DBB4D069A}" dt="2026-07-29T15:23:06.027" v="312" actId="478"/>
+          <ac:picMkLst>
+            <pc:docMk/>
+            <pc:sldMk cId="0" sldId="262"/>
+            <ac:picMk id="6" creationId="{00000000-0000-0000-0000-000000000000}"/>
+          </ac:picMkLst>
+        </pc:picChg>
       </pc:sldChg>
-      <pc:sldChg chg="modSp mod">
-        <pc:chgData name="Rodrigue YENGO" userId="9019d928-c12d-48de-bdb2-52a833805ac2" providerId="ADAL" clId="{20734E0D-FF75-44B1-9DFF-D19DBB4D069A}" dt="2026-07-28T13:31:44.235" v="142" actId="27636"/>
+      <pc:sldChg chg="delSp modSp mod">
+        <pc:chgData name="Rodrigue YENGO" userId="9019d928-c12d-48de-bdb2-52a833805ac2" providerId="ADAL" clId="{20734E0D-FF75-44B1-9DFF-D19DBB4D069A}" dt="2026-07-29T15:23:30.304" v="313" actId="478"/>
         <pc:sldMkLst>
           <pc:docMk/>
           <pc:sldMk cId="0" sldId="263"/>
         </pc:sldMkLst>
+        <pc:spChg chg="del">
+          <ac:chgData name="Rodrigue YENGO" userId="9019d928-c12d-48de-bdb2-52a833805ac2" providerId="ADAL" clId="{20734E0D-FF75-44B1-9DFF-D19DBB4D069A}" dt="2026-07-29T15:23:30.304" v="313" actId="478"/>
+          <ac:spMkLst>
+            <pc:docMk/>
+            <pc:sldMk cId="0" sldId="263"/>
+            <ac:spMk id="2" creationId="{00000000-0000-0000-0000-000000000000}"/>
+          </ac:spMkLst>
+        </pc:spChg>
         <pc:spChg chg="mod">
-          <ac:chgData name="Rodrigue YENGO" userId="9019d928-c12d-48de-bdb2-52a833805ac2" providerId="ADAL" clId="{20734E0D-FF75-44B1-9DFF-D19DBB4D069A}" dt="2026-07-28T13:31:44.235" v="142" actId="27636"/>
+          <ac:chgData name="Rodrigue YENGO" userId="9019d928-c12d-48de-bdb2-52a833805ac2" providerId="ADAL" clId="{20734E0D-FF75-44B1-9DFF-D19DBB4D069A}" dt="2026-07-29T10:52:03.263" v="193" actId="27636"/>
           <ac:spMkLst>
             <pc:docMk/>
             <pc:sldMk cId="0" sldId="263"/>
@@ -512,8 +864,124 @@
           </ac:spMkLst>
         </pc:spChg>
       </pc:sldChg>
-      <pc:sldMasterChg chg="addSp delSp modSp mod">
-        <pc:chgData name="Rodrigue YENGO" userId="9019d928-c12d-48de-bdb2-52a833805ac2" providerId="ADAL" clId="{20734E0D-FF75-44B1-9DFF-D19DBB4D069A}" dt="2026-07-28T13:33:52.860" v="146" actId="14100"/>
+      <pc:sldChg chg="addSp delSp modSp new del mod">
+        <pc:chgData name="Rodrigue YENGO" userId="9019d928-c12d-48de-bdb2-52a833805ac2" providerId="ADAL" clId="{20734E0D-FF75-44B1-9DFF-D19DBB4D069A}" dt="2026-07-29T15:22:17.484" v="300" actId="47"/>
+        <pc:sldMkLst>
+          <pc:docMk/>
+          <pc:sldMk cId="1842743097" sldId="264"/>
+        </pc:sldMkLst>
+        <pc:picChg chg="add del mod">
+          <ac:chgData name="Rodrigue YENGO" userId="9019d928-c12d-48de-bdb2-52a833805ac2" providerId="ADAL" clId="{20734E0D-FF75-44B1-9DFF-D19DBB4D069A}" dt="2026-07-29T11:03:23.354" v="198" actId="478"/>
+          <ac:picMkLst>
+            <pc:docMk/>
+            <pc:sldMk cId="1842743097" sldId="264"/>
+            <ac:picMk id="3" creationId="{8311A209-6A27-D619-B9F8-34BFD537B913}"/>
+          </ac:picMkLst>
+        </pc:picChg>
+        <pc:picChg chg="add del">
+          <ac:chgData name="Rodrigue YENGO" userId="9019d928-c12d-48de-bdb2-52a833805ac2" providerId="ADAL" clId="{20734E0D-FF75-44B1-9DFF-D19DBB4D069A}" dt="2026-07-29T15:22:06.874" v="298" actId="478"/>
+          <ac:picMkLst>
+            <pc:docMk/>
+            <pc:sldMk cId="1842743097" sldId="264"/>
+            <ac:picMk id="5" creationId="{6DFBA726-B4EF-656F-37EA-E0C9A95D3423}"/>
+          </ac:picMkLst>
+        </pc:picChg>
+      </pc:sldChg>
+      <pc:sldChg chg="addSp delSp modSp add del mod">
+        <pc:chgData name="Rodrigue YENGO" userId="9019d928-c12d-48de-bdb2-52a833805ac2" providerId="ADAL" clId="{20734E0D-FF75-44B1-9DFF-D19DBB4D069A}" dt="2026-07-29T15:22:17.484" v="300" actId="47"/>
+        <pc:sldMkLst>
+          <pc:docMk/>
+          <pc:sldMk cId="2359317237" sldId="265"/>
+        </pc:sldMkLst>
+        <pc:picChg chg="add del">
+          <ac:chgData name="Rodrigue YENGO" userId="9019d928-c12d-48de-bdb2-52a833805ac2" providerId="ADAL" clId="{20734E0D-FF75-44B1-9DFF-D19DBB4D069A}" dt="2026-07-29T11:09:57.910" v="203" actId="478"/>
+          <ac:picMkLst>
+            <pc:docMk/>
+            <pc:sldMk cId="2359317237" sldId="265"/>
+            <ac:picMk id="3" creationId="{45C20F00-BCFE-6B2D-AB85-361B9EFCC5F1}"/>
+          </ac:picMkLst>
+        </pc:picChg>
+        <pc:picChg chg="del">
+          <ac:chgData name="Rodrigue YENGO" userId="9019d928-c12d-48de-bdb2-52a833805ac2" providerId="ADAL" clId="{20734E0D-FF75-44B1-9DFF-D19DBB4D069A}" dt="2026-07-29T11:03:33.677" v="201" actId="478"/>
+          <ac:picMkLst>
+            <pc:docMk/>
+            <pc:sldMk cId="2359317237" sldId="265"/>
+            <ac:picMk id="5" creationId="{1A45F883-FCE1-8B5D-C921-0F01F666B443}"/>
+          </ac:picMkLst>
+        </pc:picChg>
+        <pc:picChg chg="add del mod">
+          <ac:chgData name="Rodrigue YENGO" userId="9019d928-c12d-48de-bdb2-52a833805ac2" providerId="ADAL" clId="{20734E0D-FF75-44B1-9DFF-D19DBB4D069A}" dt="2026-07-29T15:22:11.128" v="299" actId="478"/>
+          <ac:picMkLst>
+            <pc:docMk/>
+            <pc:sldMk cId="2359317237" sldId="265"/>
+            <ac:picMk id="6" creationId="{B36F0AEE-3287-E234-4373-542EEA64998E}"/>
+          </ac:picMkLst>
+        </pc:picChg>
+      </pc:sldChg>
+      <pc:sldChg chg="addSp delSp modSp add del mod">
+        <pc:chgData name="Rodrigue YENGO" userId="9019d928-c12d-48de-bdb2-52a833805ac2" providerId="ADAL" clId="{20734E0D-FF75-44B1-9DFF-D19DBB4D069A}" dt="2026-07-29T15:22:17.484" v="300" actId="47"/>
+        <pc:sldMkLst>
+          <pc:docMk/>
+          <pc:sldMk cId="2693075688" sldId="266"/>
+        </pc:sldMkLst>
+        <pc:picChg chg="add mod">
+          <ac:chgData name="Rodrigue YENGO" userId="9019d928-c12d-48de-bdb2-52a833805ac2" providerId="ADAL" clId="{20734E0D-FF75-44B1-9DFF-D19DBB4D069A}" dt="2026-07-29T11:31:37.244" v="211" actId="1076"/>
+          <ac:picMkLst>
+            <pc:docMk/>
+            <pc:sldMk cId="2693075688" sldId="266"/>
+            <ac:picMk id="3" creationId="{BD0288F6-2407-5884-9102-3CE06676C50F}"/>
+          </ac:picMkLst>
+        </pc:picChg>
+        <pc:picChg chg="del">
+          <ac:chgData name="Rodrigue YENGO" userId="9019d928-c12d-48de-bdb2-52a833805ac2" providerId="ADAL" clId="{20734E0D-FF75-44B1-9DFF-D19DBB4D069A}" dt="2026-07-29T11:31:08.337" v="206" actId="478"/>
+          <ac:picMkLst>
+            <pc:docMk/>
+            <pc:sldMk cId="2693075688" sldId="266"/>
+            <ac:picMk id="6" creationId="{B1382932-6C06-D00E-C4FD-A39903BFF333}"/>
+          </ac:picMkLst>
+        </pc:picChg>
+      </pc:sldChg>
+      <pc:sldChg chg="addSp delSp modSp add del mod">
+        <pc:chgData name="Rodrigue YENGO" userId="9019d928-c12d-48de-bdb2-52a833805ac2" providerId="ADAL" clId="{20734E0D-FF75-44B1-9DFF-D19DBB4D069A}" dt="2026-07-29T15:22:17.484" v="300" actId="47"/>
+        <pc:sldMkLst>
+          <pc:docMk/>
+          <pc:sldMk cId="1353077044" sldId="267"/>
+        </pc:sldMkLst>
+        <pc:picChg chg="del">
+          <ac:chgData name="Rodrigue YENGO" userId="9019d928-c12d-48de-bdb2-52a833805ac2" providerId="ADAL" clId="{20734E0D-FF75-44B1-9DFF-D19DBB4D069A}" dt="2026-07-29T12:03:39.261" v="213" actId="478"/>
+          <ac:picMkLst>
+            <pc:docMk/>
+            <pc:sldMk cId="1353077044" sldId="267"/>
+            <ac:picMk id="3" creationId="{33D3D045-EB3E-8117-9F67-98E16B5DDFB1}"/>
+          </ac:picMkLst>
+        </pc:picChg>
+        <pc:picChg chg="add del">
+          <ac:chgData name="Rodrigue YENGO" userId="9019d928-c12d-48de-bdb2-52a833805ac2" providerId="ADAL" clId="{20734E0D-FF75-44B1-9DFF-D19DBB4D069A}" dt="2026-07-29T12:04:12.619" v="215" actId="478"/>
+          <ac:picMkLst>
+            <pc:docMk/>
+            <pc:sldMk cId="1353077044" sldId="267"/>
+            <ac:picMk id="4" creationId="{BCF3251B-1AC1-4514-87B2-D26F5E0D38D7}"/>
+          </ac:picMkLst>
+        </pc:picChg>
+        <pc:picChg chg="add mod">
+          <ac:chgData name="Rodrigue YENGO" userId="9019d928-c12d-48de-bdb2-52a833805ac2" providerId="ADAL" clId="{20734E0D-FF75-44B1-9DFF-D19DBB4D069A}" dt="2026-07-29T12:04:15.892" v="217" actId="1076"/>
+          <ac:picMkLst>
+            <pc:docMk/>
+            <pc:sldMk cId="1353077044" sldId="267"/>
+            <ac:picMk id="6" creationId="{C56D6A7D-CFD6-0A4C-58A1-53E4201DA9B4}"/>
+          </ac:picMkLst>
+        </pc:picChg>
+        <pc:picChg chg="add mod">
+          <ac:chgData name="Rodrigue YENGO" userId="9019d928-c12d-48de-bdb2-52a833805ac2" providerId="ADAL" clId="{20734E0D-FF75-44B1-9DFF-D19DBB4D069A}" dt="2026-07-29T12:04:38.239" v="219" actId="1076"/>
+          <ac:picMkLst>
+            <pc:docMk/>
+            <pc:sldMk cId="1353077044" sldId="267"/>
+            <ac:picMk id="8" creationId="{CB4528DE-C558-C9DB-3CD7-FCE4A01BA61E}"/>
+          </ac:picMkLst>
+        </pc:picChg>
+      </pc:sldChg>
+      <pc:sldMasterChg chg="addSp delSp modSp mod modSldLayout">
+        <pc:chgData name="Rodrigue YENGO" userId="9019d928-c12d-48de-bdb2-52a833805ac2" providerId="ADAL" clId="{20734E0D-FF75-44B1-9DFF-D19DBB4D069A}" dt="2026-07-29T17:11:06.417" v="390" actId="22"/>
         <pc:sldMasterMkLst>
           <pc:docMk/>
           <pc:sldMasterMk cId="0" sldId="2147483648"/>
@@ -526,6 +994,14 @@
             <ac:spMk id="5" creationId="{60D89672-FBB5-E3A8-AFD3-E2602FA9B229}"/>
           </ac:spMkLst>
         </pc:spChg>
+        <pc:picChg chg="add">
+          <ac:chgData name="Rodrigue YENGO" userId="9019d928-c12d-48de-bdb2-52a833805ac2" providerId="ADAL" clId="{20734E0D-FF75-44B1-9DFF-D19DBB4D069A}" dt="2026-07-29T17:11:06.417" v="390" actId="22"/>
+          <ac:picMkLst>
+            <pc:docMk/>
+            <pc:sldMasterMk cId="0" sldId="2147483648"/>
+            <ac:picMk id="3" creationId="{1036526E-AA57-E3FE-08B4-E1DAE0AC8F06}"/>
+          </ac:picMkLst>
+        </pc:picChg>
         <pc:picChg chg="add del mod">
           <ac:chgData name="Rodrigue YENGO" userId="9019d928-c12d-48de-bdb2-52a833805ac2" providerId="ADAL" clId="{20734E0D-FF75-44B1-9DFF-D19DBB4D069A}" dt="2026-07-28T13:31:43.601" v="101" actId="22"/>
           <ac:picMkLst>
@@ -535,13 +1011,111 @@
           </ac:picMkLst>
         </pc:picChg>
         <pc:picChg chg="add mod">
-          <ac:chgData name="Rodrigue YENGO" userId="9019d928-c12d-48de-bdb2-52a833805ac2" providerId="ADAL" clId="{20734E0D-FF75-44B1-9DFF-D19DBB4D069A}" dt="2026-07-28T13:33:52.860" v="146" actId="14100"/>
+          <ac:chgData name="Rodrigue YENGO" userId="9019d928-c12d-48de-bdb2-52a833805ac2" providerId="ADAL" clId="{20734E0D-FF75-44B1-9DFF-D19DBB4D069A}" dt="2026-07-29T15:50:12.738" v="314" actId="14100"/>
           <ac:picMkLst>
             <pc:docMk/>
             <pc:sldMasterMk cId="0" sldId="2147483648"/>
             <ac:picMk id="7" creationId="{C9A920E7-E3E8-E0F7-3BDB-D8174FB00FBD}"/>
           </ac:picMkLst>
         </pc:picChg>
+        <pc:sldLayoutChg chg="addSp delSp modSp mod setBg">
+          <pc:chgData name="Rodrigue YENGO" userId="9019d928-c12d-48de-bdb2-52a833805ac2" providerId="ADAL" clId="{20734E0D-FF75-44B1-9DFF-D19DBB4D069A}" dt="2026-07-29T17:11:03.019" v="389" actId="478"/>
+          <pc:sldLayoutMkLst>
+            <pc:docMk/>
+            <pc:sldMasterMk cId="0" sldId="2147483648"/>
+            <pc:sldLayoutMk cId="0" sldId="2147483649"/>
+          </pc:sldLayoutMkLst>
+          <pc:spChg chg="add del">
+            <ac:chgData name="Rodrigue YENGO" userId="9019d928-c12d-48de-bdb2-52a833805ac2" providerId="ADAL" clId="{20734E0D-FF75-44B1-9DFF-D19DBB4D069A}" dt="2026-07-29T10:51:35.437" v="152" actId="22"/>
+            <ac:spMkLst>
+              <pc:docMk/>
+              <pc:sldMasterMk cId="0" sldId="2147483648"/>
+              <pc:sldLayoutMk cId="0" sldId="2147483649"/>
+              <ac:spMk id="3" creationId="{0F5DDFDD-1350-6E62-339B-C514DA465BC8}"/>
+            </ac:spMkLst>
+          </pc:spChg>
+          <pc:spChg chg="add">
+            <ac:chgData name="Rodrigue YENGO" userId="9019d928-c12d-48de-bdb2-52a833805ac2" providerId="ADAL" clId="{20734E0D-FF75-44B1-9DFF-D19DBB4D069A}" dt="2026-07-29T10:52:05.033" v="194" actId="22"/>
+            <ac:spMkLst>
+              <pc:docMk/>
+              <pc:sldMasterMk cId="0" sldId="2147483648"/>
+              <pc:sldLayoutMk cId="0" sldId="2147483649"/>
+              <ac:spMk id="5" creationId="{7907A6CC-405A-1488-B29C-D022A017603A}"/>
+            </ac:spMkLst>
+          </pc:spChg>
+          <pc:spChg chg="add mod">
+            <ac:chgData name="Rodrigue YENGO" userId="9019d928-c12d-48de-bdb2-52a833805ac2" providerId="ADAL" clId="{20734E0D-FF75-44B1-9DFF-D19DBB4D069A}" dt="2026-07-29T15:19:52.716" v="285" actId="1035"/>
+            <ac:spMkLst>
+              <pc:docMk/>
+              <pc:sldMasterMk cId="0" sldId="2147483648"/>
+              <pc:sldLayoutMk cId="0" sldId="2147483649"/>
+              <ac:spMk id="7" creationId="{E9537A2A-E3B1-89E0-BD29-DFD88322CDBA}"/>
+            </ac:spMkLst>
+          </pc:spChg>
+          <pc:spChg chg="add mod">
+            <ac:chgData name="Rodrigue YENGO" userId="9019d928-c12d-48de-bdb2-52a833805ac2" providerId="ADAL" clId="{20734E0D-FF75-44B1-9DFF-D19DBB4D069A}" dt="2026-07-29T15:20:29.184" v="289" actId="14100"/>
+            <ac:spMkLst>
+              <pc:docMk/>
+              <pc:sldMasterMk cId="0" sldId="2147483648"/>
+              <pc:sldLayoutMk cId="0" sldId="2147483649"/>
+              <ac:spMk id="9" creationId="{3559D478-16CC-042D-1B1B-53876A38FF08}"/>
+            </ac:spMkLst>
+          </pc:spChg>
+          <pc:spChg chg="add mod">
+            <ac:chgData name="Rodrigue YENGO" userId="9019d928-c12d-48de-bdb2-52a833805ac2" providerId="ADAL" clId="{20734E0D-FF75-44B1-9DFF-D19DBB4D069A}" dt="2026-07-29T15:20:29.184" v="289" actId="14100"/>
+            <ac:spMkLst>
+              <pc:docMk/>
+              <pc:sldMasterMk cId="0" sldId="2147483648"/>
+              <pc:sldLayoutMk cId="0" sldId="2147483649"/>
+              <ac:spMk id="11" creationId="{9A745354-E2E2-1A71-CA70-CA85D9ACCEEC}"/>
+            </ac:spMkLst>
+          </pc:spChg>
+          <pc:spChg chg="add mod">
+            <ac:chgData name="Rodrigue YENGO" userId="9019d928-c12d-48de-bdb2-52a833805ac2" providerId="ADAL" clId="{20734E0D-FF75-44B1-9DFF-D19DBB4D069A}" dt="2026-07-29T15:20:29.184" v="289" actId="14100"/>
+            <ac:spMkLst>
+              <pc:docMk/>
+              <pc:sldMasterMk cId="0" sldId="2147483648"/>
+              <pc:sldLayoutMk cId="0" sldId="2147483649"/>
+              <ac:spMk id="13" creationId="{81F0C328-23F8-2EE6-F2A2-DECD0C595986}"/>
+            </ac:spMkLst>
+          </pc:spChg>
+          <pc:picChg chg="add del">
+            <ac:chgData name="Rodrigue YENGO" userId="9019d928-c12d-48de-bdb2-52a833805ac2" providerId="ADAL" clId="{20734E0D-FF75-44B1-9DFF-D19DBB4D069A}" dt="2026-07-29T16:15:35.342" v="336" actId="478"/>
+            <ac:picMkLst>
+              <pc:docMk/>
+              <pc:sldMasterMk cId="0" sldId="2147483648"/>
+              <pc:sldLayoutMk cId="0" sldId="2147483649"/>
+              <ac:picMk id="2" creationId="{03F28F91-9217-5A90-D365-83AA550ECB96}"/>
+            </ac:picMkLst>
+          </pc:picChg>
+          <pc:picChg chg="add del mod">
+            <ac:chgData name="Rodrigue YENGO" userId="9019d928-c12d-48de-bdb2-52a833805ac2" providerId="ADAL" clId="{20734E0D-FF75-44B1-9DFF-D19DBB4D069A}" dt="2026-07-29T16:43:00.031" v="342" actId="478"/>
+            <ac:picMkLst>
+              <pc:docMk/>
+              <pc:sldMasterMk cId="0" sldId="2147483648"/>
+              <pc:sldLayoutMk cId="0" sldId="2147483649"/>
+              <ac:picMk id="4" creationId="{75D1D28D-E9D2-B3B4-8777-78E56A943E18}"/>
+            </ac:picMkLst>
+          </pc:picChg>
+          <pc:picChg chg="add del mod">
+            <ac:chgData name="Rodrigue YENGO" userId="9019d928-c12d-48de-bdb2-52a833805ac2" providerId="ADAL" clId="{20734E0D-FF75-44B1-9DFF-D19DBB4D069A}" dt="2026-07-29T16:42:57.821" v="341" actId="478"/>
+            <ac:picMkLst>
+              <pc:docMk/>
+              <pc:sldMasterMk cId="0" sldId="2147483648"/>
+              <pc:sldLayoutMk cId="0" sldId="2147483649"/>
+              <ac:picMk id="8" creationId="{148B1349-94FC-B811-3E44-428839E55C41}"/>
+            </ac:picMkLst>
+          </pc:picChg>
+          <pc:picChg chg="add del mod">
+            <ac:chgData name="Rodrigue YENGO" userId="9019d928-c12d-48de-bdb2-52a833805ac2" providerId="ADAL" clId="{20734E0D-FF75-44B1-9DFF-D19DBB4D069A}" dt="2026-07-29T17:11:03.019" v="389" actId="478"/>
+            <ac:picMkLst>
+              <pc:docMk/>
+              <pc:sldMasterMk cId="0" sldId="2147483648"/>
+              <pc:sldLayoutMk cId="0" sldId="2147483649"/>
+              <ac:picMk id="12" creationId="{3317BCF3-001A-B069-B173-A781AFC20B47}"/>
+            </ac:picMkLst>
+          </pc:picChg>
+        </pc:sldLayoutChg>
       </pc:sldMasterChg>
     </pc:docChg>
   </pc:docChgLst>
@@ -1367,9 +1941,12 @@
 <p:sldLayout xmlns:a="http://schemas.openxmlformats.org/drawingml/2006/main" xmlns:r="http://schemas.openxmlformats.org/officeDocument/2006/relationships" xmlns:p="http://schemas.openxmlformats.org/presentationml/2006/main" preserve="1">
   <p:cSld name="DEFAULT">
     <p:bg>
-      <p:bgRef idx="1001">
-        <a:schemeClr val="bg1"/>
-      </p:bgRef>
+      <p:bgPr>
+        <a:solidFill>
+          <a:schemeClr val="tx1"/>
+        </a:solidFill>
+        <a:effectLst/>
+      </p:bgPr>
     </p:bg>
     <p:spTree>
       <p:nvGrpSpPr>
@@ -1385,6 +1962,254 @@
           <a:chExt cx="0" cy="0"/>
         </a:xfrm>
       </p:grpSpPr>
+      <p:sp>
+        <p:nvSpPr>
+          <p:cNvPr id="5" name="Shape 0">
+            <a:extLst>
+              <a:ext uri="{FF2B5EF4-FFF2-40B4-BE49-F238E27FC236}">
+                <a16:creationId xmlns:a16="http://schemas.microsoft.com/office/drawing/2014/main" id="{7907A6CC-405A-1488-B29C-D022A017603A}"/>
+              </a:ext>
+            </a:extLst>
+          </p:cNvPr>
+          <p:cNvSpPr/>
+          <p:nvPr userDrawn="1"/>
+        </p:nvSpPr>
+        <p:spPr>
+          <a:xfrm>
+            <a:off x="0" y="0"/>
+            <a:ext cx="18288000" cy="10287000"/>
+          </a:xfrm>
+          <a:prstGeom prst="rect">
+            <a:avLst/>
+          </a:prstGeom>
+          <a:gradFill rotWithShape="1">
+            <a:gsLst>
+              <a:gs pos="0">
+                <a:srgbClr val="2B2741">
+                  <a:alpha val="75000"/>
+                </a:srgbClr>
+              </a:gs>
+              <a:gs pos="58000">
+                <a:srgbClr val="2B2741">
+                  <a:alpha val="0"/>
+                </a:srgbClr>
+              </a:gs>
+            </a:gsLst>
+            <a:path path="circle">
+              <a:fillToRect l="80000" r="20000" b="100000"/>
+            </a:path>
+          </a:gradFill>
+          <a:ln/>
+        </p:spPr>
+        <p:txBody>
+          <a:bodyPr/>
+          <a:lstStyle/>
+          <a:p>
+            <a:endParaRPr lang="en-GB"/>
+          </a:p>
+        </p:txBody>
+      </p:sp>
+      <p:sp>
+        <p:nvSpPr>
+          <p:cNvPr id="7" name="Shape 0">
+            <a:extLst>
+              <a:ext uri="{FF2B5EF4-FFF2-40B4-BE49-F238E27FC236}">
+                <a16:creationId xmlns:a16="http://schemas.microsoft.com/office/drawing/2014/main" id="{E9537A2A-E3B1-89E0-BD29-DFD88322CDBA}"/>
+              </a:ext>
+            </a:extLst>
+          </p:cNvPr>
+          <p:cNvSpPr/>
+          <p:nvPr userDrawn="1"/>
+        </p:nvSpPr>
+        <p:spPr>
+          <a:xfrm>
+            <a:off x="-4768" y="-19053"/>
+            <a:ext cx="18288000" cy="10287000"/>
+          </a:xfrm>
+          <a:prstGeom prst="rect">
+            <a:avLst/>
+          </a:prstGeom>
+          <a:gradFill rotWithShape="1">
+            <a:gsLst>
+              <a:gs pos="0">
+                <a:srgbClr val="2B2741">
+                  <a:alpha val="75000"/>
+                </a:srgbClr>
+              </a:gs>
+              <a:gs pos="58000">
+                <a:srgbClr val="2B2741">
+                  <a:alpha val="0"/>
+                </a:srgbClr>
+              </a:gs>
+            </a:gsLst>
+            <a:path path="circle">
+              <a:fillToRect l="80000" r="20000" b="100000"/>
+            </a:path>
+          </a:gradFill>
+          <a:ln/>
+        </p:spPr>
+        <p:txBody>
+          <a:bodyPr/>
+          <a:lstStyle/>
+          <a:p>
+            <a:endParaRPr lang="en-GB" dirty="0"/>
+          </a:p>
+        </p:txBody>
+      </p:sp>
+      <p:sp>
+        <p:nvSpPr>
+          <p:cNvPr id="9" name="Text 1">
+            <a:extLst>
+              <a:ext uri="{FF2B5EF4-FFF2-40B4-BE49-F238E27FC236}">
+                <a16:creationId xmlns:a16="http://schemas.microsoft.com/office/drawing/2014/main" id="{3559D478-16CC-042D-1B1B-53876A38FF08}"/>
+              </a:ext>
+            </a:extLst>
+          </p:cNvPr>
+          <p:cNvSpPr/>
+          <p:nvPr userDrawn="1"/>
+        </p:nvSpPr>
+        <p:spPr>
+          <a:xfrm>
+            <a:off x="1143000" y="685651"/>
+            <a:ext cx="4437221" cy="385912"/>
+          </a:xfrm>
+          <a:prstGeom prst="rect">
+            <a:avLst/>
+          </a:prstGeom>
+          <a:noFill/>
+          <a:ln/>
+        </p:spPr>
+        <p:txBody>
+          <a:bodyPr wrap="square" lIns="25400" tIns="25400" rIns="25400" bIns="25400" rtlCol="0" anchor="t">
+            <a:noAutofit/>
+          </a:bodyPr>
+          <a:lstStyle/>
+          <a:p>
+            <a:pPr marL="0" indent="0" algn="l">
+              <a:lnSpc>
+                <a:spcPct val="131154"/>
+              </a:lnSpc>
+              <a:buNone/>
+            </a:pPr>
+            <a:r>
+              <a:rPr lang="en-US" sz="1400" kern="0" spc="99" dirty="0">
+                <a:solidFill>
+                  <a:srgbClr val="9184D9"/>
+                </a:solidFill>
+                <a:latin typeface="Arial" pitchFamily="34" charset="0"/>
+                <a:ea typeface="Arial" pitchFamily="34" charset="-122"/>
+                <a:cs typeface="Arial" pitchFamily="34" charset="-120"/>
+              </a:rPr>
+              <a:t>JOUR 1 · MODULE 1 · 09:00 – 10:45</a:t>
+            </a:r>
+            <a:endParaRPr lang="en-US" sz="1400" dirty="0"/>
+          </a:p>
+        </p:txBody>
+      </p:sp>
+      <p:sp>
+        <p:nvSpPr>
+          <p:cNvPr id="11" name="Text 4">
+            <a:extLst>
+              <a:ext uri="{FF2B5EF4-FFF2-40B4-BE49-F238E27FC236}">
+                <a16:creationId xmlns:a16="http://schemas.microsoft.com/office/drawing/2014/main" id="{9A745354-E2E2-1A71-CA70-CA85D9ACCEEC}"/>
+              </a:ext>
+            </a:extLst>
+          </p:cNvPr>
+          <p:cNvSpPr/>
+          <p:nvPr userDrawn="1"/>
+        </p:nvSpPr>
+        <p:spPr>
+          <a:xfrm>
+            <a:off x="1143000" y="9296400"/>
+            <a:ext cx="3245078" cy="385912"/>
+          </a:xfrm>
+          <a:prstGeom prst="rect">
+            <a:avLst/>
+          </a:prstGeom>
+          <a:noFill/>
+          <a:ln/>
+        </p:spPr>
+        <p:txBody>
+          <a:bodyPr wrap="square" lIns="25400" tIns="25400" rIns="25400" bIns="25400" rtlCol="0" anchor="t">
+            <a:noAutofit/>
+          </a:bodyPr>
+          <a:lstStyle/>
+          <a:p>
+            <a:pPr marL="0" indent="0" algn="l">
+              <a:lnSpc>
+                <a:spcPct val="131154"/>
+              </a:lnSpc>
+              <a:buNone/>
+            </a:pPr>
+            <a:r>
+              <a:rPr lang="en-US" sz="1400" dirty="0">
+                <a:solidFill>
+                  <a:srgbClr val="E9E9ED">
+                    <a:alpha val="55000"/>
+                  </a:srgbClr>
+                </a:solidFill>
+                <a:latin typeface="Arial" pitchFamily="34" charset="0"/>
+                <a:ea typeface="Arial" pitchFamily="34" charset="-122"/>
+                <a:cs typeface="Arial" pitchFamily="34" charset="-120"/>
+              </a:rPr>
+              <a:t>Data &amp; AI France Study Group</a:t>
+            </a:r>
+            <a:endParaRPr lang="en-US" sz="1400" dirty="0"/>
+          </a:p>
+        </p:txBody>
+      </p:sp>
+      <p:sp>
+        <p:nvSpPr>
+          <p:cNvPr id="13" name="Text 6">
+            <a:extLst>
+              <a:ext uri="{FF2B5EF4-FFF2-40B4-BE49-F238E27FC236}">
+                <a16:creationId xmlns:a16="http://schemas.microsoft.com/office/drawing/2014/main" id="{81F0C328-23F8-2EE6-F2A2-DECD0C595986}"/>
+              </a:ext>
+            </a:extLst>
+          </p:cNvPr>
+          <p:cNvSpPr/>
+          <p:nvPr userDrawn="1"/>
+        </p:nvSpPr>
+        <p:spPr>
+          <a:xfrm>
+            <a:off x="4496395" y="9296400"/>
+            <a:ext cx="9936272" cy="385912"/>
+          </a:xfrm>
+          <a:prstGeom prst="rect">
+            <a:avLst/>
+          </a:prstGeom>
+          <a:noFill/>
+          <a:ln/>
+        </p:spPr>
+        <p:txBody>
+          <a:bodyPr wrap="square" lIns="25400" tIns="25400" rIns="25400" bIns="25400" rtlCol="0" anchor="t">
+            <a:noAutofit/>
+          </a:bodyPr>
+          <a:lstStyle/>
+          <a:p>
+            <a:pPr marL="0" indent="0" algn="l">
+              <a:lnSpc>
+                <a:spcPct val="131154"/>
+              </a:lnSpc>
+              <a:buNone/>
+            </a:pPr>
+            <a:r>
+              <a:rPr lang="en-US" sz="1400" dirty="0">
+                <a:solidFill>
+                  <a:srgbClr val="E9E9ED">
+                    <a:alpha val="55000"/>
+                  </a:srgbClr>
+                </a:solidFill>
+                <a:latin typeface="Arial" pitchFamily="34" charset="0"/>
+                <a:ea typeface="Arial" pitchFamily="34" charset="-122"/>
+                <a:cs typeface="Arial" pitchFamily="34" charset="-120"/>
+              </a:rPr>
+              <a:t>Data Days — DP-800 · Développer des solutions de base de données compatibles avec l'IA</a:t>
+            </a:r>
+            <a:endParaRPr lang="en-US" sz="1400" dirty="0"/>
+          </a:p>
+        </p:txBody>
+      </p:sp>
     </p:spTree>
   </p:cSld>
   <p:clrMapOvr>
@@ -1437,8 +2262,38 @@
         </p:blipFill>
         <p:spPr>
           <a:xfrm>
-            <a:off x="16576430" y="194733"/>
-            <a:ext cx="1851269" cy="1234180"/>
+            <a:off x="16732737" y="194733"/>
+            <a:ext cx="1694962" cy="1129975"/>
+          </a:xfrm>
+          <a:prstGeom prst="rect">
+            <a:avLst/>
+          </a:prstGeom>
+        </p:spPr>
+      </p:pic>
+      <p:pic>
+        <p:nvPicPr>
+          <p:cNvPr id="3" name="Image 2">
+            <a:extLst>
+              <a:ext uri="{FF2B5EF4-FFF2-40B4-BE49-F238E27FC236}">
+                <a16:creationId xmlns:a16="http://schemas.microsoft.com/office/drawing/2014/main" id="{1036526E-AA57-E3FE-08B4-E1DAE0AC8F06}"/>
+              </a:ext>
+            </a:extLst>
+          </p:cNvPr>
+          <p:cNvPicPr>
+            <a:picLocks noChangeAspect="1"/>
+          </p:cNvPicPr>
+          <p:nvPr userDrawn="1"/>
+        </p:nvPicPr>
+        <p:blipFill>
+          <a:blip r:embed="rId4"/>
+          <a:stretch>
+            <a:fillRect/>
+          </a:stretch>
+        </p:blipFill>
+        <p:spPr>
+          <a:xfrm>
+            <a:off x="1218000" y="8316939"/>
+            <a:ext cx="2951271" cy="1141158"/>
           </a:xfrm>
           <a:prstGeom prst="rect">
             <a:avLst/>
@@ -1732,109 +2587,24 @@
       </p:grpSpPr>
       <p:sp>
         <p:nvSpPr>
-          <p:cNvPr id="2" name="Shape 0"/>
+          <p:cNvPr id="4" name="Text 2"/>
           <p:cNvSpPr/>
           <p:nvPr/>
         </p:nvSpPr>
         <p:spPr>
           <a:xfrm>
-            <a:off x="0" y="0"/>
-            <a:ext cx="18288000" cy="10287000"/>
+            <a:off x="1085851" y="3939480"/>
+            <a:ext cx="9438422" cy="960090"/>
           </a:xfrm>
           <a:prstGeom prst="rect">
             <a:avLst/>
           </a:prstGeom>
-          <a:gradFill rotWithShape="1">
-            <a:gsLst>
-              <a:gs pos="0">
-                <a:srgbClr val="2B2741">
-                  <a:alpha val="75000"/>
-                </a:srgbClr>
-              </a:gs>
-              <a:gs pos="58000">
-                <a:srgbClr val="2B2741">
-                  <a:alpha val="0"/>
-                </a:srgbClr>
-              </a:gs>
-            </a:gsLst>
-            <a:path path="circle">
-              <a:fillToRect l="80000" r="20000" b="100000"/>
-            </a:path>
-          </a:gradFill>
-          <a:ln/>
-        </p:spPr>
-        <p:txBody>
-          <a:bodyPr/>
-          <a:lstStyle/>
-          <a:p>
-            <a:endParaRPr lang="en-GB"/>
-          </a:p>
-        </p:txBody>
-      </p:sp>
-      <p:sp>
-        <p:nvSpPr>
-          <p:cNvPr id="3" name="Text 1"/>
-          <p:cNvSpPr/>
-          <p:nvPr/>
-        </p:nvSpPr>
-        <p:spPr>
-          <a:xfrm>
-            <a:off x="1143000" y="685651"/>
-            <a:ext cx="4437221" cy="190500"/>
-          </a:xfrm>
-          <a:prstGeom prst="rect">
-            <a:avLst/>
-          </a:prstGeom>
           <a:noFill/>
           <a:ln/>
         </p:spPr>
         <p:txBody>
           <a:bodyPr wrap="square" lIns="25400" tIns="25400" rIns="25400" bIns="25400" rtlCol="0" anchor="t">
-            <a:normAutofit/>
-          </a:bodyPr>
-          <a:lstStyle/>
-          <a:p>
-            <a:pPr marL="0" indent="0" algn="l">
-              <a:lnSpc>
-                <a:spcPct val="131154"/>
-              </a:lnSpc>
-              <a:buNone/>
-            </a:pPr>
-            <a:r>
-              <a:rPr lang="en-US" sz="1650" kern="0" spc="99" dirty="0">
-                <a:solidFill>
-                  <a:srgbClr val="9184D9"/>
-                </a:solidFill>
-                <a:latin typeface="Arial" pitchFamily="34" charset="0"/>
-                <a:ea typeface="Arial" pitchFamily="34" charset="-122"/>
-                <a:cs typeface="Arial" pitchFamily="34" charset="-120"/>
-              </a:rPr>
-              <a:t>JOUR 1 · MODULE 1 · 09:00 – 10:45</a:t>
-            </a:r>
-            <a:endParaRPr lang="en-US" sz="1650" dirty="0"/>
-          </a:p>
-        </p:txBody>
-      </p:sp>
-      <p:sp>
-        <p:nvSpPr>
-          <p:cNvPr id="4" name="Text 2"/>
-          <p:cNvSpPr/>
-          <p:nvPr/>
-        </p:nvSpPr>
-        <p:spPr>
-          <a:xfrm>
-            <a:off x="1085850" y="3939480"/>
-            <a:ext cx="17665065" cy="960090"/>
-          </a:xfrm>
-          <a:prstGeom prst="rect">
-            <a:avLst/>
-          </a:prstGeom>
-          <a:noFill/>
-          <a:ln/>
-        </p:spPr>
-        <p:txBody>
-          <a:bodyPr wrap="square" lIns="25400" tIns="25400" rIns="25400" bIns="25400" rtlCol="0" anchor="t">
-            <a:normAutofit/>
+            <a:noAutofit/>
           </a:bodyPr>
           <a:lstStyle/>
           <a:p>
@@ -1853,7 +2623,26 @@
                 <a:ea typeface="Arial" pitchFamily="34" charset="-122"/>
                 <a:cs typeface="Arial" pitchFamily="34" charset="-120"/>
               </a:rPr>
-              <a:t>Objets de base de données</a:t>
+              <a:t>Objets de base de </a:t>
+            </a:r>
+          </a:p>
+          <a:p>
+            <a:pPr marL="0" indent="0" algn="l">
+              <a:lnSpc>
+                <a:spcPct val="84174"/>
+              </a:lnSpc>
+              <a:buNone/>
+            </a:pPr>
+            <a:r>
+              <a:rPr lang="en-US" sz="7500" kern="0" spc="-150" dirty="0">
+                <a:solidFill>
+                  <a:srgbClr val="E9E9ED"/>
+                </a:solidFill>
+                <a:latin typeface="Arial" pitchFamily="34" charset="0"/>
+                <a:ea typeface="Arial" pitchFamily="34" charset="-122"/>
+                <a:cs typeface="Arial" pitchFamily="34" charset="-120"/>
+              </a:rPr>
+              <a:t>données</a:t>
             </a:r>
             <a:endParaRPr lang="en-US" sz="7500" dirty="0"/>
           </a:p>
@@ -1867,7 +2656,7 @@
         </p:nvSpPr>
         <p:spPr>
           <a:xfrm>
-            <a:off x="1143000" y="5166271"/>
+            <a:off x="1143000" y="6495012"/>
             <a:ext cx="8912453" cy="1295400"/>
           </a:xfrm>
           <a:prstGeom prst="rect">
@@ -1878,7 +2667,7 @@
         </p:spPr>
         <p:txBody>
           <a:bodyPr wrap="square" lIns="25400" tIns="25400" rIns="25400" bIns="25400" rtlCol="0" anchor="t">
-            <a:normAutofit/>
+            <a:normAutofit lnSpcReduction="10000"/>
           </a:bodyPr>
           <a:lstStyle/>
           <a:p>
@@ -1905,14 +2694,14 @@
       </p:sp>
       <p:sp>
         <p:nvSpPr>
-          <p:cNvPr id="6" name="Text 4"/>
+          <p:cNvPr id="7" name="Text 5"/>
           <p:cNvSpPr/>
           <p:nvPr/>
         </p:nvSpPr>
         <p:spPr>
           <a:xfrm>
-            <a:off x="1143000" y="9296400"/>
-            <a:ext cx="3245078" cy="190500"/>
+            <a:off x="4264521" y="9296400"/>
+            <a:ext cx="136624" cy="190500"/>
           </a:xfrm>
           <a:prstGeom prst="rect">
             <a:avLst/>
@@ -1922,53 +2711,7 @@
         </p:spPr>
         <p:txBody>
           <a:bodyPr wrap="square" lIns="25400" tIns="25400" rIns="25400" bIns="25400" rtlCol="0" anchor="t">
-            <a:normAutofit/>
-          </a:bodyPr>
-          <a:lstStyle/>
-          <a:p>
-            <a:pPr marL="0" indent="0" algn="l">
-              <a:lnSpc>
-                <a:spcPct val="131154"/>
-              </a:lnSpc>
-              <a:buNone/>
-            </a:pPr>
-            <a:r>
-              <a:rPr lang="en-US" sz="1650" dirty="0">
-                <a:solidFill>
-                  <a:srgbClr val="E9E9ED">
-                    <a:alpha val="55000"/>
-                  </a:srgbClr>
-                </a:solidFill>
-                <a:latin typeface="Arial" pitchFamily="34" charset="0"/>
-                <a:ea typeface="Arial" pitchFamily="34" charset="-122"/>
-                <a:cs typeface="Arial" pitchFamily="34" charset="-120"/>
-              </a:rPr>
-              <a:t>Data &amp; AI France Study Group</a:t>
-            </a:r>
-            <a:endParaRPr lang="en-US" sz="1650" dirty="0"/>
-          </a:p>
-        </p:txBody>
-      </p:sp>
-      <p:sp>
-        <p:nvSpPr>
-          <p:cNvPr id="7" name="Text 5"/>
-          <p:cNvSpPr/>
-          <p:nvPr/>
-        </p:nvSpPr>
-        <p:spPr>
-          <a:xfrm>
-            <a:off x="4264521" y="9296400"/>
-            <a:ext cx="136624" cy="190500"/>
-          </a:xfrm>
-          <a:prstGeom prst="rect">
-            <a:avLst/>
-          </a:prstGeom>
-          <a:noFill/>
-          <a:ln/>
-        </p:spPr>
-        <p:txBody>
-          <a:bodyPr wrap="square" lIns="25400" tIns="25400" rIns="25400" bIns="25400" rtlCol="0" anchor="t">
-            <a:normAutofit/>
+            <a:normAutofit fontScale="47500" lnSpcReduction="20000"/>
           </a:bodyPr>
           <a:lstStyle/>
           <a:p>
@@ -1995,49 +2738,290 @@
           </a:p>
         </p:txBody>
       </p:sp>
-      <p:sp>
-        <p:nvSpPr>
-          <p:cNvPr id="8" name="Text 6"/>
-          <p:cNvSpPr/>
+      <p:grpSp>
+        <p:nvGrpSpPr>
+          <p:cNvPr id="25" name="Groupe 24">
+            <a:extLst>
+              <a:ext uri="{FF2B5EF4-FFF2-40B4-BE49-F238E27FC236}">
+                <a16:creationId xmlns:a16="http://schemas.microsoft.com/office/drawing/2014/main" id="{D3B55B10-A2FD-2E32-13F7-D0A2B472DE93}"/>
+              </a:ext>
+            </a:extLst>
+          </p:cNvPr>
+          <p:cNvGrpSpPr/>
           <p:nvPr/>
-        </p:nvSpPr>
-        <p:spPr>
-          <a:xfrm>
-            <a:off x="4496395" y="9296400"/>
-            <a:ext cx="9936272" cy="190500"/>
-          </a:xfrm>
-          <a:prstGeom prst="rect">
+        </p:nvGrpSpPr>
+        <p:grpSpPr>
+          <a:xfrm>
+            <a:off x="10505982" y="561196"/>
+            <a:ext cx="6990490" cy="8735204"/>
+            <a:chOff x="11002220" y="561196"/>
+            <a:chExt cx="6990490" cy="8735204"/>
+          </a:xfrm>
+        </p:grpSpPr>
+        <p:pic>
+          <p:nvPicPr>
+            <p:cNvPr id="26" name="Image 25">
+              <a:extLst>
+                <a:ext uri="{FF2B5EF4-FFF2-40B4-BE49-F238E27FC236}">
+                  <a16:creationId xmlns:a16="http://schemas.microsoft.com/office/drawing/2014/main" id="{E66C4808-9747-E827-82F0-34C53DF93851}"/>
+                </a:ext>
+              </a:extLst>
+            </p:cNvPr>
+            <p:cNvPicPr>
+              <a:picLocks noChangeAspect="1"/>
+            </p:cNvPicPr>
+            <p:nvPr/>
+          </p:nvPicPr>
+          <p:blipFill>
+            <a:blip r:embed="rId3"/>
+            <a:stretch>
+              <a:fillRect/>
+            </a:stretch>
+          </p:blipFill>
+          <p:spPr>
+            <a:xfrm>
+              <a:off x="11002220" y="4636074"/>
+              <a:ext cx="6990490" cy="4660326"/>
+            </a:xfrm>
+            <a:prstGeom prst="rect">
+              <a:avLst/>
+            </a:prstGeom>
+          </p:spPr>
+        </p:pic>
+        <p:pic>
+          <p:nvPicPr>
+            <p:cNvPr id="27" name="Image 26">
+              <a:extLst>
+                <a:ext uri="{FF2B5EF4-FFF2-40B4-BE49-F238E27FC236}">
+                  <a16:creationId xmlns:a16="http://schemas.microsoft.com/office/drawing/2014/main" id="{D3E7D007-039A-92D6-43F9-F6C510974154}"/>
+                </a:ext>
+              </a:extLst>
+            </p:cNvPr>
+            <p:cNvPicPr>
+              <a:picLocks noChangeAspect="1"/>
+            </p:cNvPicPr>
+            <p:nvPr/>
+          </p:nvPicPr>
+          <p:blipFill>
+            <a:blip r:embed="rId4"/>
+            <a:stretch>
+              <a:fillRect/>
+            </a:stretch>
+          </p:blipFill>
+          <p:spPr>
+            <a:xfrm>
+              <a:off x="14823713" y="565257"/>
+              <a:ext cx="2808967" cy="2808967"/>
+            </a:xfrm>
+            <a:prstGeom prst="ellipse">
+              <a:avLst/>
+            </a:prstGeom>
+            <a:ln w="3175" cap="rnd">
+              <a:solidFill>
+                <a:srgbClr val="C8C6BD"/>
+              </a:solidFill>
+              <a:prstDash val="solid"/>
+            </a:ln>
+            <a:effectLst>
+              <a:outerShdw blurRad="127000" algn="bl" rotWithShape="0">
+                <a:srgbClr val="000000"/>
+              </a:outerShdw>
+            </a:effectLst>
+            <a:scene3d>
+              <a:camera prst="perspectiveFront" fov="5400000"/>
+              <a:lightRig rig="threePt" dir="t">
+                <a:rot lat="0" lon="0" rev="19200000"/>
+              </a:lightRig>
+            </a:scene3d>
+            <a:sp3d extrusionH="25400">
+              <a:bevelT w="304800" h="152400" prst="hardEdge"/>
+              <a:extrusionClr>
+                <a:srgbClr val="000000"/>
+              </a:extrusionClr>
+            </a:sp3d>
+          </p:spPr>
+        </p:pic>
+        <p:pic>
+          <p:nvPicPr>
+            <p:cNvPr id="28" name="Image 27">
+              <a:extLst>
+                <a:ext uri="{FF2B5EF4-FFF2-40B4-BE49-F238E27FC236}">
+                  <a16:creationId xmlns:a16="http://schemas.microsoft.com/office/drawing/2014/main" id="{F90629BD-61A3-18FF-A5F1-9A0EC7C03C14}"/>
+                </a:ext>
+              </a:extLst>
+            </p:cNvPr>
+            <p:cNvPicPr>
+              <a:picLocks noChangeAspect="1"/>
+            </p:cNvPicPr>
+            <p:nvPr/>
+          </p:nvPicPr>
+          <p:blipFill>
+            <a:blip r:embed="rId5"/>
+            <a:stretch>
+              <a:fillRect/>
+            </a:stretch>
+          </p:blipFill>
+          <p:spPr>
+            <a:xfrm>
+              <a:off x="11636328" y="561196"/>
+              <a:ext cx="2807208" cy="2807208"/>
+            </a:xfrm>
+            <a:prstGeom prst="ellipse">
+              <a:avLst/>
+            </a:prstGeom>
+            <a:ln w="3175" cap="rnd">
+              <a:solidFill>
+                <a:srgbClr val="C8C6BD"/>
+              </a:solidFill>
+              <a:prstDash val="solid"/>
+            </a:ln>
+            <a:effectLst>
+              <a:outerShdw blurRad="127000" algn="bl" rotWithShape="0">
+                <a:srgbClr val="000000"/>
+              </a:outerShdw>
+            </a:effectLst>
+            <a:scene3d>
+              <a:camera prst="perspectiveFront" fov="5400000"/>
+              <a:lightRig rig="threePt" dir="t">
+                <a:rot lat="0" lon="0" rev="19200000"/>
+              </a:lightRig>
+            </a:scene3d>
+            <a:sp3d extrusionH="25400">
+              <a:bevelT w="304800" h="152400" prst="hardEdge"/>
+              <a:extrusionClr>
+                <a:srgbClr val="000000"/>
+              </a:extrusionClr>
+            </a:sp3d>
+          </p:spPr>
+        </p:pic>
+        <p:sp>
+          <p:nvSpPr>
+            <p:cNvPr id="29" name="ZoneTexte 28">
+              <a:extLst>
+                <a:ext uri="{FF2B5EF4-FFF2-40B4-BE49-F238E27FC236}">
+                  <a16:creationId xmlns:a16="http://schemas.microsoft.com/office/drawing/2014/main" id="{BFAFCE9F-F655-DE5E-8623-A55D3352A71A}"/>
+                </a:ext>
+              </a:extLst>
+            </p:cNvPr>
+            <p:cNvSpPr txBox="1"/>
+            <p:nvPr/>
+          </p:nvSpPr>
+          <p:spPr>
+            <a:xfrm>
+              <a:off x="14889480" y="3668223"/>
+              <a:ext cx="2743200" cy="461665"/>
+            </a:xfrm>
+            <a:prstGeom prst="rect">
+              <a:avLst/>
+            </a:prstGeom>
+            <a:noFill/>
+          </p:spPr>
+          <p:txBody>
+            <a:bodyPr wrap="square">
+              <a:spAutoFit/>
+            </a:bodyPr>
+            <a:lstStyle/>
+            <a:p>
+              <a:pPr lvl="0"/>
+              <a:r>
+                <a:rPr lang="en-US" sz="2400" i="0" kern="1200" dirty="0">
+                  <a:solidFill>
+                    <a:schemeClr val="bg1"/>
+                  </a:solidFill>
+                  <a:effectLst/>
+                  <a:latin typeface="+mn-lt"/>
+                  <a:ea typeface="+mn-ea"/>
+                  <a:cs typeface="+mn-cs"/>
+                </a:rPr>
+                <a:t>Abdelhak BENYAHIA</a:t>
+              </a:r>
+            </a:p>
+          </p:txBody>
+        </p:sp>
+        <p:sp>
+          <p:nvSpPr>
+            <p:cNvPr id="30" name="ZoneTexte 29">
+              <a:extLst>
+                <a:ext uri="{FF2B5EF4-FFF2-40B4-BE49-F238E27FC236}">
+                  <a16:creationId xmlns:a16="http://schemas.microsoft.com/office/drawing/2014/main" id="{1D18B29D-19A7-958F-EDFF-28AB111EC413}"/>
+                </a:ext>
+              </a:extLst>
+            </p:cNvPr>
+            <p:cNvSpPr txBox="1"/>
+            <p:nvPr/>
+          </p:nvSpPr>
+          <p:spPr>
+            <a:xfrm>
+              <a:off x="11668332" y="3668223"/>
+              <a:ext cx="2743200" cy="461665"/>
+            </a:xfrm>
+            <a:prstGeom prst="rect">
+              <a:avLst/>
+            </a:prstGeom>
+            <a:noFill/>
+          </p:spPr>
+          <p:txBody>
+            <a:bodyPr wrap="square">
+              <a:spAutoFit/>
+            </a:bodyPr>
+            <a:lstStyle/>
+            <a:p>
+              <a:pPr lvl="0"/>
+              <a:r>
+                <a:rPr lang="en-US" sz="2400" dirty="0">
+                  <a:solidFill>
+                    <a:schemeClr val="bg1"/>
+                  </a:solidFill>
+                </a:rPr>
+                <a:t>Rodrigue YENGO</a:t>
+              </a:r>
+            </a:p>
+          </p:txBody>
+        </p:sp>
+      </p:grpSp>
+      <p:sp>
+        <p:nvSpPr>
+          <p:cNvPr id="9" name="Rectangle : coins arrondis 8">
+            <a:extLst>
+              <a:ext uri="{FF2B5EF4-FFF2-40B4-BE49-F238E27FC236}">
+                <a16:creationId xmlns:a16="http://schemas.microsoft.com/office/drawing/2014/main" id="{6F49019B-5F4D-555C-A52F-B88B715642CE}"/>
+              </a:ext>
+            </a:extLst>
+          </p:cNvPr>
+          <p:cNvSpPr/>
+          <p:nvPr/>
+        </p:nvSpPr>
+        <p:spPr>
+          <a:xfrm>
+            <a:off x="7842738" y="-187569"/>
+            <a:ext cx="914400" cy="914400"/>
+          </a:xfrm>
+          <a:prstGeom prst="roundRect">
             <a:avLst/>
           </a:prstGeom>
-          <a:noFill/>
-          <a:ln/>
-        </p:spPr>
-        <p:txBody>
-          <a:bodyPr wrap="square" lIns="25400" tIns="25400" rIns="25400" bIns="25400" rtlCol="0" anchor="t">
-            <a:normAutofit/>
-          </a:bodyPr>
-          <a:lstStyle/>
-          <a:p>
-            <a:pPr marL="0" indent="0" algn="l">
-              <a:lnSpc>
-                <a:spcPct val="131154"/>
-              </a:lnSpc>
-              <a:buNone/>
-            </a:pPr>
-            <a:r>
-              <a:rPr lang="en-US" sz="1650" dirty="0">
-                <a:solidFill>
-                  <a:srgbClr val="E9E9ED">
-                    <a:alpha val="55000"/>
-                  </a:srgbClr>
-                </a:solidFill>
-                <a:latin typeface="Arial" pitchFamily="34" charset="0"/>
-                <a:ea typeface="Arial" pitchFamily="34" charset="-122"/>
-                <a:cs typeface="Arial" pitchFamily="34" charset="-120"/>
-              </a:rPr>
-              <a:t>Data Days — DP-800 · Développer des solutions de base de données compatibles avec l'IA</a:t>
-            </a:r>
-            <a:endParaRPr lang="en-US" sz="1650" dirty="0"/>
+        </p:spPr>
+        <p:style>
+          <a:lnRef idx="2">
+            <a:schemeClr val="accent1">
+              <a:shade val="15000"/>
+            </a:schemeClr>
+          </a:lnRef>
+          <a:fillRef idx="1">
+            <a:schemeClr val="accent1"/>
+          </a:fillRef>
+          <a:effectRef idx="0">
+            <a:schemeClr val="accent1"/>
+          </a:effectRef>
+          <a:fontRef idx="minor">
+            <a:schemeClr val="lt1"/>
+          </a:fontRef>
+        </p:style>
+        <p:txBody>
+          <a:bodyPr rtlCol="0" anchor="ctr"/>
+          <a:lstStyle/>
+          <a:p>
+            <a:pPr algn="ctr"/>
+            <a:endParaRPr lang="en-GB"/>
           </a:p>
         </p:txBody>
       </p:sp>
@@ -2076,109 +3060,24 @@
       </p:grpSpPr>
       <p:sp>
         <p:nvSpPr>
-          <p:cNvPr id="2" name="Shape 0"/>
+          <p:cNvPr id="4" name="Text 2"/>
           <p:cNvSpPr/>
           <p:nvPr/>
         </p:nvSpPr>
         <p:spPr>
           <a:xfrm>
-            <a:off x="0" y="0"/>
-            <a:ext cx="18288000" cy="10287000"/>
+            <a:off x="1109960" y="1693664"/>
+            <a:ext cx="17638544" cy="440085"/>
           </a:xfrm>
           <a:prstGeom prst="rect">
             <a:avLst/>
           </a:prstGeom>
-          <a:gradFill rotWithShape="1">
-            <a:gsLst>
-              <a:gs pos="0">
-                <a:srgbClr val="2B2741">
-                  <a:alpha val="75000"/>
-                </a:srgbClr>
-              </a:gs>
-              <a:gs pos="58000">
-                <a:srgbClr val="2B2741">
-                  <a:alpha val="0"/>
-                </a:srgbClr>
-              </a:gs>
-            </a:gsLst>
-            <a:path path="circle">
-              <a:fillToRect l="80000" r="20000" b="100000"/>
-            </a:path>
-          </a:gradFill>
-          <a:ln/>
-        </p:spPr>
-        <p:txBody>
-          <a:bodyPr/>
-          <a:lstStyle/>
-          <a:p>
-            <a:endParaRPr lang="en-GB"/>
-          </a:p>
-        </p:txBody>
-      </p:sp>
-      <p:sp>
-        <p:nvSpPr>
-          <p:cNvPr id="3" name="Text 1"/>
-          <p:cNvSpPr/>
-          <p:nvPr/>
-        </p:nvSpPr>
-        <p:spPr>
-          <a:xfrm>
-            <a:off x="1143000" y="685651"/>
-            <a:ext cx="2467124" cy="190500"/>
-          </a:xfrm>
-          <a:prstGeom prst="rect">
-            <a:avLst/>
-          </a:prstGeom>
           <a:noFill/>
           <a:ln/>
         </p:spPr>
         <p:txBody>
           <a:bodyPr wrap="square" lIns="25400" tIns="25400" rIns="25400" bIns="25400" rtlCol="0" anchor="t">
-            <a:normAutofit/>
-          </a:bodyPr>
-          <a:lstStyle/>
-          <a:p>
-            <a:pPr marL="0" indent="0" algn="l">
-              <a:lnSpc>
-                <a:spcPct val="131154"/>
-              </a:lnSpc>
-              <a:buNone/>
-            </a:pPr>
-            <a:r>
-              <a:rPr lang="en-US" sz="1650" kern="0" spc="99" dirty="0">
-                <a:solidFill>
-                  <a:srgbClr val="9184D9"/>
-                </a:solidFill>
-                <a:latin typeface="Arial" pitchFamily="34" charset="0"/>
-                <a:ea typeface="Arial" pitchFamily="34" charset="-122"/>
-                <a:cs typeface="Arial" pitchFamily="34" charset="-120"/>
-              </a:rPr>
-              <a:t>JOUR 1 · MODULE 1</a:t>
-            </a:r>
-            <a:endParaRPr lang="en-US" sz="1650" dirty="0"/>
-          </a:p>
-        </p:txBody>
-      </p:sp>
-      <p:sp>
-        <p:nvSpPr>
-          <p:cNvPr id="4" name="Text 2"/>
-          <p:cNvSpPr/>
-          <p:nvPr/>
-        </p:nvSpPr>
-        <p:spPr>
-          <a:xfrm>
-            <a:off x="1109960" y="1693664"/>
-            <a:ext cx="17638544" cy="440085"/>
-          </a:xfrm>
-          <a:prstGeom prst="rect">
-            <a:avLst/>
-          </a:prstGeom>
-          <a:noFill/>
-          <a:ln/>
-        </p:spPr>
-        <p:txBody>
-          <a:bodyPr wrap="square" lIns="25400" tIns="25400" rIns="25400" bIns="25400" rtlCol="0" anchor="t">
-            <a:normAutofit/>
+            <a:normAutofit fontScale="70000" lnSpcReduction="20000"/>
           </a:bodyPr>
           <a:lstStyle/>
           <a:p>
@@ -2277,7 +3176,7 @@
           <a:bodyPr/>
           <a:lstStyle/>
           <a:p>
-            <a:endParaRPr lang="en-GB"/>
+            <a:endParaRPr lang="en-GB" sz="2000"/>
           </a:p>
         </p:txBody>
       </p:sp>
@@ -2300,7 +3199,7 @@
         </p:spPr>
         <p:txBody>
           <a:bodyPr wrap="square" lIns="25400" tIns="25400" rIns="25400" bIns="25400" rtlCol="0" anchor="ctr">
-            <a:normAutofit/>
+            <a:noAutofit/>
           </a:bodyPr>
           <a:lstStyle/>
           <a:p>
@@ -2311,7 +3210,7 @@
               <a:buNone/>
             </a:pPr>
             <a:r>
-              <a:rPr lang="en-US" sz="1650" kern="0" spc="132" dirty="0">
+              <a:rPr lang="en-US" sz="2000" kern="0" spc="132" dirty="0">
                 <a:solidFill>
                   <a:srgbClr val="E9E9ED"/>
                 </a:solidFill>
@@ -2321,7 +3220,7 @@
               </a:rPr>
               <a:t>HEURE</a:t>
             </a:r>
-            <a:endParaRPr lang="en-US" sz="1650" dirty="0"/>
+            <a:endParaRPr lang="en-US" sz="2000" dirty="0"/>
           </a:p>
         </p:txBody>
       </p:sp>
@@ -2350,7 +3249,7 @@
           <a:bodyPr/>
           <a:lstStyle/>
           <a:p>
-            <a:endParaRPr lang="en-GB"/>
+            <a:endParaRPr lang="en-GB" sz="2000"/>
           </a:p>
         </p:txBody>
       </p:sp>
@@ -2373,7 +3272,7 @@
         </p:spPr>
         <p:txBody>
           <a:bodyPr wrap="square" lIns="25400" tIns="25400" rIns="25400" bIns="25400" rtlCol="0" anchor="ctr">
-            <a:normAutofit/>
+            <a:noAutofit/>
           </a:bodyPr>
           <a:lstStyle/>
           <a:p>
@@ -2384,7 +3283,7 @@
               <a:buNone/>
             </a:pPr>
             <a:r>
-              <a:rPr lang="en-US" sz="1650" kern="0" spc="132" dirty="0">
+              <a:rPr lang="en-US" sz="2000" kern="0" spc="132" dirty="0">
                 <a:solidFill>
                   <a:srgbClr val="EAEAEC">
                     <a:alpha val="70000"/>
@@ -2396,7 +3295,7 @@
               </a:rPr>
               <a:t>SÉQUENCE</a:t>
             </a:r>
-            <a:endParaRPr lang="en-US" sz="1650" dirty="0"/>
+            <a:endParaRPr lang="en-US" sz="2000" dirty="0"/>
           </a:p>
         </p:txBody>
       </p:sp>
@@ -2474,7 +3373,7 @@
           <a:bodyPr/>
           <a:lstStyle/>
           <a:p>
-            <a:endParaRPr lang="en-GB"/>
+            <a:endParaRPr lang="en-GB" sz="2000"/>
           </a:p>
         </p:txBody>
       </p:sp>
@@ -2497,7 +3396,7 @@
         </p:spPr>
         <p:txBody>
           <a:bodyPr wrap="square" lIns="25400" tIns="25400" rIns="25400" bIns="25400" rtlCol="0" anchor="ctr">
-            <a:normAutofit/>
+            <a:noAutofit/>
           </a:bodyPr>
           <a:lstStyle/>
           <a:p>
@@ -2508,7 +3407,7 @@
               <a:buNone/>
             </a:pPr>
             <a:r>
-              <a:rPr lang="en-US" sz="2100" dirty="0">
+              <a:rPr lang="en-US" sz="2000" dirty="0">
                 <a:solidFill>
                   <a:srgbClr val="E9E9ED"/>
                 </a:solidFill>
@@ -2518,7 +3417,7 @@
               </a:rPr>
               <a:t>09:00</a:t>
             </a:r>
-            <a:endParaRPr lang="en-US" sz="2100" dirty="0"/>
+            <a:endParaRPr lang="en-US" sz="2000" dirty="0"/>
           </a:p>
         </p:txBody>
       </p:sp>
@@ -2547,7 +3446,7 @@
           <a:bodyPr/>
           <a:lstStyle/>
           <a:p>
-            <a:endParaRPr lang="en-GB"/>
+            <a:endParaRPr lang="en-GB" sz="2000"/>
           </a:p>
         </p:txBody>
       </p:sp>
@@ -2570,7 +3469,7 @@
         </p:spPr>
         <p:txBody>
           <a:bodyPr wrap="square" lIns="25400" tIns="25400" rIns="25400" bIns="25400" rtlCol="0" anchor="ctr">
-            <a:normAutofit/>
+            <a:noAutofit/>
           </a:bodyPr>
           <a:lstStyle/>
           <a:p>
@@ -2581,7 +3480,7 @@
               <a:buNone/>
             </a:pPr>
             <a:r>
-              <a:rPr lang="en-US" sz="2100" dirty="0">
+              <a:rPr lang="en-US" sz="2000" dirty="0">
                 <a:solidFill>
                   <a:srgbClr val="E4E7F5"/>
                 </a:solidFill>
@@ -2591,7 +3490,7 @@
               </a:rPr>
               <a:t>Choisir la plateforme SQL adaptée au besoin</a:t>
             </a:r>
-            <a:endParaRPr lang="en-US" sz="2100" dirty="0"/>
+            <a:endParaRPr lang="en-US" sz="2000" dirty="0"/>
           </a:p>
         </p:txBody>
       </p:sp>
@@ -2669,7 +3568,7 @@
           <a:bodyPr/>
           <a:lstStyle/>
           <a:p>
-            <a:endParaRPr lang="en-GB"/>
+            <a:endParaRPr lang="en-GB" sz="2000"/>
           </a:p>
         </p:txBody>
       </p:sp>
@@ -2692,7 +3591,7 @@
         </p:spPr>
         <p:txBody>
           <a:bodyPr wrap="square" lIns="25400" tIns="25400" rIns="25400" bIns="25400" rtlCol="0" anchor="ctr">
-            <a:normAutofit/>
+            <a:noAutofit/>
           </a:bodyPr>
           <a:lstStyle/>
           <a:p>
@@ -2703,7 +3602,7 @@
               <a:buNone/>
             </a:pPr>
             <a:r>
-              <a:rPr lang="en-US" sz="2100" dirty="0">
+              <a:rPr lang="en-US" sz="2000" dirty="0">
                 <a:solidFill>
                   <a:srgbClr val="E9E9ED"/>
                 </a:solidFill>
@@ -2713,7 +3612,7 @@
               </a:rPr>
               <a:t>09:20</a:t>
             </a:r>
-            <a:endParaRPr lang="en-US" sz="2100" dirty="0"/>
+            <a:endParaRPr lang="en-US" sz="2000" dirty="0"/>
           </a:p>
         </p:txBody>
       </p:sp>
@@ -2742,7 +3641,7 @@
           <a:bodyPr/>
           <a:lstStyle/>
           <a:p>
-            <a:endParaRPr lang="en-GB"/>
+            <a:endParaRPr lang="en-GB" sz="2000"/>
           </a:p>
         </p:txBody>
       </p:sp>
@@ -2765,7 +3664,7 @@
         </p:spPr>
         <p:txBody>
           <a:bodyPr wrap="square" lIns="25400" tIns="25400" rIns="25400" bIns="25400" rtlCol="0" anchor="ctr">
-            <a:normAutofit/>
+            <a:noAutofit/>
           </a:bodyPr>
           <a:lstStyle/>
           <a:p>
@@ -2776,7 +3675,7 @@
               <a:buNone/>
             </a:pPr>
             <a:r>
-              <a:rPr lang="en-US" sz="2100" dirty="0">
+              <a:rPr lang="en-US" sz="2000" dirty="0">
                 <a:solidFill>
                   <a:srgbClr val="E4E7F5"/>
                 </a:solidFill>
@@ -2786,7 +3685,7 @@
               </a:rPr>
               <a:t>Tables, types de données et index spécialisés</a:t>
             </a:r>
-            <a:endParaRPr lang="en-US" sz="2100" dirty="0"/>
+            <a:endParaRPr lang="en-US" sz="2000" dirty="0"/>
           </a:p>
         </p:txBody>
       </p:sp>
@@ -2864,7 +3763,7 @@
           <a:bodyPr/>
           <a:lstStyle/>
           <a:p>
-            <a:endParaRPr lang="en-GB"/>
+            <a:endParaRPr lang="en-GB" sz="2000"/>
           </a:p>
         </p:txBody>
       </p:sp>
@@ -2887,7 +3786,7 @@
         </p:spPr>
         <p:txBody>
           <a:bodyPr wrap="square" lIns="25400" tIns="25400" rIns="25400" bIns="25400" rtlCol="0" anchor="ctr">
-            <a:normAutofit/>
+            <a:noAutofit/>
           </a:bodyPr>
           <a:lstStyle/>
           <a:p>
@@ -2898,7 +3797,7 @@
               <a:buNone/>
             </a:pPr>
             <a:r>
-              <a:rPr lang="en-US" sz="2100" dirty="0">
+              <a:rPr lang="en-US" sz="2000" dirty="0">
                 <a:solidFill>
                   <a:srgbClr val="E9E9ED"/>
                 </a:solidFill>
@@ -2908,7 +3807,7 @@
               </a:rPr>
               <a:t>10:00</a:t>
             </a:r>
-            <a:endParaRPr lang="en-US" sz="2100" dirty="0"/>
+            <a:endParaRPr lang="en-US" sz="2000" dirty="0"/>
           </a:p>
         </p:txBody>
       </p:sp>
@@ -2937,7 +3836,7 @@
           <a:bodyPr/>
           <a:lstStyle/>
           <a:p>
-            <a:endParaRPr lang="en-GB"/>
+            <a:endParaRPr lang="en-GB" sz="2000"/>
           </a:p>
         </p:txBody>
       </p:sp>
@@ -2960,7 +3859,7 @@
         </p:spPr>
         <p:txBody>
           <a:bodyPr wrap="square" lIns="25400" tIns="25400" rIns="25400" bIns="25400" rtlCol="0" anchor="ctr">
-            <a:normAutofit/>
+            <a:noAutofit/>
           </a:bodyPr>
           <a:lstStyle/>
           <a:p>
@@ -2971,7 +3870,7 @@
               <a:buNone/>
             </a:pPr>
             <a:r>
-              <a:rPr lang="en-US" sz="2100" dirty="0">
+              <a:rPr lang="en-US" sz="2000" dirty="0">
                 <a:solidFill>
                   <a:srgbClr val="E4E7F5"/>
                 </a:solidFill>
@@ -2981,7 +3880,7 @@
               </a:rPr>
               <a:t>Démo : étendre le schéma fil rouge en direct</a:t>
             </a:r>
-            <a:endParaRPr lang="en-US" sz="2100" dirty="0"/>
+            <a:endParaRPr lang="en-US" sz="2000" dirty="0"/>
           </a:p>
         </p:txBody>
       </p:sp>
@@ -3059,7 +3958,7 @@
           <a:bodyPr/>
           <a:lstStyle/>
           <a:p>
-            <a:endParaRPr lang="en-GB"/>
+            <a:endParaRPr lang="en-GB" sz="2000"/>
           </a:p>
         </p:txBody>
       </p:sp>
@@ -3082,7 +3981,7 @@
         </p:spPr>
         <p:txBody>
           <a:bodyPr wrap="square" lIns="25400" tIns="25400" rIns="25400" bIns="25400" rtlCol="0" anchor="ctr">
-            <a:normAutofit/>
+            <a:noAutofit/>
           </a:bodyPr>
           <a:lstStyle/>
           <a:p>
@@ -3093,7 +3992,7 @@
               <a:buNone/>
             </a:pPr>
             <a:r>
-              <a:rPr lang="en-US" sz="2100" dirty="0">
+              <a:rPr lang="en-US" sz="2000" dirty="0">
                 <a:solidFill>
                   <a:srgbClr val="E9E9ED"/>
                 </a:solidFill>
@@ -3103,7 +4002,7 @@
               </a:rPr>
               <a:t>10:30</a:t>
             </a:r>
-            <a:endParaRPr lang="en-US" sz="2100" dirty="0"/>
+            <a:endParaRPr lang="en-US" sz="2000" dirty="0"/>
           </a:p>
         </p:txBody>
       </p:sp>
@@ -3132,7 +4031,7 @@
           <a:bodyPr/>
           <a:lstStyle/>
           <a:p>
-            <a:endParaRPr lang="en-GB"/>
+            <a:endParaRPr lang="en-GB" sz="2000"/>
           </a:p>
         </p:txBody>
       </p:sp>
@@ -3155,7 +4054,7 @@
         </p:spPr>
         <p:txBody>
           <a:bodyPr wrap="square" lIns="25400" tIns="25400" rIns="25400" bIns="25400" rtlCol="0" anchor="ctr">
-            <a:normAutofit/>
+            <a:noAutofit/>
           </a:bodyPr>
           <a:lstStyle/>
           <a:p>
@@ -3166,7 +4065,7 @@
               <a:buNone/>
             </a:pPr>
             <a:r>
-              <a:rPr lang="en-US" sz="2100" dirty="0">
+              <a:rPr lang="en-US" sz="2000" dirty="0">
                 <a:solidFill>
                   <a:srgbClr val="E4E7F5"/>
                 </a:solidFill>
@@ -3176,34 +4075,10 @@
               </a:rPr>
               <a:t>Contrôle des connaissances et résumé</a:t>
             </a:r>
-            <a:endParaRPr lang="en-US" sz="2100" dirty="0"/>
-          </a:p>
-        </p:txBody>
-      </p:sp>
-      <p:pic>
-        <p:nvPicPr>
-          <p:cNvPr id="30" name="Image 0" descr="preencoded.png"/>
-          <p:cNvPicPr>
-            <a:picLocks noChangeAspect="1"/>
-          </p:cNvPicPr>
-          <p:nvPr/>
-        </p:nvPicPr>
-        <p:blipFill>
-          <a:blip r:embed="rId3"/>
-          <a:stretch>
-            <a:fillRect/>
-          </a:stretch>
-        </p:blipFill>
-        <p:spPr>
-          <a:xfrm>
-            <a:off x="11167765" y="9867900"/>
-            <a:ext cx="5977235" cy="152400"/>
-          </a:xfrm>
-          <a:prstGeom prst="rect">
-            <a:avLst/>
-          </a:prstGeom>
-        </p:spPr>
-      </p:pic>
+            <a:endParaRPr lang="en-US" sz="2000" dirty="0"/>
+          </a:p>
+        </p:txBody>
+      </p:sp>
     </p:spTree>
   </p:cSld>
   <p:clrMapOvr>
@@ -3239,109 +4114,24 @@
       </p:grpSpPr>
       <p:sp>
         <p:nvSpPr>
-          <p:cNvPr id="2" name="Shape 0"/>
+          <p:cNvPr id="4" name="Text 2"/>
           <p:cNvSpPr/>
           <p:nvPr/>
         </p:nvSpPr>
         <p:spPr>
           <a:xfrm>
-            <a:off x="0" y="0"/>
-            <a:ext cx="18288000" cy="10287000"/>
+            <a:off x="1109960" y="1693664"/>
+            <a:ext cx="17638544" cy="440085"/>
           </a:xfrm>
           <a:prstGeom prst="rect">
             <a:avLst/>
           </a:prstGeom>
-          <a:gradFill rotWithShape="1">
-            <a:gsLst>
-              <a:gs pos="0">
-                <a:srgbClr val="2B2741">
-                  <a:alpha val="75000"/>
-                </a:srgbClr>
-              </a:gs>
-              <a:gs pos="58000">
-                <a:srgbClr val="2B2741">
-                  <a:alpha val="0"/>
-                </a:srgbClr>
-              </a:gs>
-            </a:gsLst>
-            <a:path path="circle">
-              <a:fillToRect l="80000" r="20000" b="100000"/>
-            </a:path>
-          </a:gradFill>
-          <a:ln/>
-        </p:spPr>
-        <p:txBody>
-          <a:bodyPr/>
-          <a:lstStyle/>
-          <a:p>
-            <a:endParaRPr lang="en-GB"/>
-          </a:p>
-        </p:txBody>
-      </p:sp>
-      <p:sp>
-        <p:nvSpPr>
-          <p:cNvPr id="3" name="Text 1"/>
-          <p:cNvSpPr/>
-          <p:nvPr/>
-        </p:nvSpPr>
-        <p:spPr>
-          <a:xfrm>
-            <a:off x="1143000" y="685651"/>
-            <a:ext cx="1811953" cy="190500"/>
-          </a:xfrm>
-          <a:prstGeom prst="rect">
-            <a:avLst/>
-          </a:prstGeom>
           <a:noFill/>
           <a:ln/>
         </p:spPr>
         <p:txBody>
           <a:bodyPr wrap="square" lIns="25400" tIns="25400" rIns="25400" bIns="25400" rtlCol="0" anchor="t">
-            <a:normAutofit/>
-          </a:bodyPr>
-          <a:lstStyle/>
-          <a:p>
-            <a:pPr marL="0" indent="0" algn="l">
-              <a:lnSpc>
-                <a:spcPct val="131154"/>
-              </a:lnSpc>
-              <a:buNone/>
-            </a:pPr>
-            <a:r>
-              <a:rPr lang="en-US" sz="1650" kern="0" spc="99" dirty="0">
-                <a:solidFill>
-                  <a:srgbClr val="9184D9"/>
-                </a:solidFill>
-                <a:latin typeface="Arial" pitchFamily="34" charset="0"/>
-                <a:ea typeface="Arial" pitchFamily="34" charset="-122"/>
-                <a:cs typeface="Arial" pitchFamily="34" charset="-120"/>
-              </a:rPr>
-              <a:t>PLATEFORMES</a:t>
-            </a:r>
-            <a:endParaRPr lang="en-US" sz="1650" dirty="0"/>
-          </a:p>
-        </p:txBody>
-      </p:sp>
-      <p:sp>
-        <p:nvSpPr>
-          <p:cNvPr id="4" name="Text 2"/>
-          <p:cNvSpPr/>
-          <p:nvPr/>
-        </p:nvSpPr>
-        <p:spPr>
-          <a:xfrm>
-            <a:off x="1109960" y="1693664"/>
-            <a:ext cx="17638544" cy="440085"/>
-          </a:xfrm>
-          <a:prstGeom prst="rect">
-            <a:avLst/>
-          </a:prstGeom>
-          <a:noFill/>
-          <a:ln/>
-        </p:spPr>
-        <p:txBody>
-          <a:bodyPr wrap="square" lIns="25400" tIns="25400" rIns="25400" bIns="25400" rtlCol="0" anchor="t">
-            <a:normAutofit/>
+            <a:normAutofit fontScale="70000" lnSpcReduction="20000"/>
           </a:bodyPr>
           <a:lstStyle/>
           <a:p>
@@ -3426,7 +4216,7 @@
         </p:spPr>
         <p:txBody>
           <a:bodyPr wrap="square" lIns="25400" tIns="25400" rIns="25400" bIns="25400" rtlCol="0" anchor="t">
-            <a:normAutofit/>
+            <a:normAutofit lnSpcReduction="10000"/>
           </a:bodyPr>
           <a:lstStyle/>
           <a:p>
@@ -3470,7 +4260,7 @@
         </p:spPr>
         <p:txBody>
           <a:bodyPr wrap="square" lIns="25400" tIns="25400" rIns="25400" bIns="25400" rtlCol="0" anchor="t">
-            <a:normAutofit/>
+            <a:normAutofit lnSpcReduction="10000"/>
           </a:bodyPr>
           <a:lstStyle/>
           <a:p>
@@ -3555,7 +4345,7 @@
         </p:spPr>
         <p:txBody>
           <a:bodyPr wrap="square" lIns="25400" tIns="25400" rIns="25400" bIns="25400" rtlCol="0" anchor="t">
-            <a:normAutofit/>
+            <a:normAutofit lnSpcReduction="10000"/>
           </a:bodyPr>
           <a:lstStyle/>
           <a:p>
@@ -3599,7 +4389,7 @@
         </p:spPr>
         <p:txBody>
           <a:bodyPr wrap="square" lIns="25400" tIns="25400" rIns="25400" bIns="25400" rtlCol="0" anchor="t">
-            <a:normAutofit/>
+            <a:normAutofit lnSpcReduction="10000"/>
           </a:bodyPr>
           <a:lstStyle/>
           <a:p>
@@ -3684,7 +4474,7 @@
         </p:spPr>
         <p:txBody>
           <a:bodyPr wrap="square" lIns="25400" tIns="25400" rIns="25400" bIns="25400" rtlCol="0" anchor="t">
-            <a:normAutofit/>
+            <a:normAutofit lnSpcReduction="10000"/>
           </a:bodyPr>
           <a:lstStyle/>
           <a:p>
@@ -3753,30 +4543,6 @@
           </a:p>
         </p:txBody>
       </p:sp>
-      <p:pic>
-        <p:nvPicPr>
-          <p:cNvPr id="14" name="Image 0" descr="preencoded.png"/>
-          <p:cNvPicPr>
-            <a:picLocks noChangeAspect="1"/>
-          </p:cNvPicPr>
-          <p:nvPr/>
-        </p:nvPicPr>
-        <p:blipFill>
-          <a:blip r:embed="rId3"/>
-          <a:stretch>
-            <a:fillRect/>
-          </a:stretch>
-        </p:blipFill>
-        <p:spPr>
-          <a:xfrm>
-            <a:off x="11167765" y="9867900"/>
-            <a:ext cx="5977235" cy="152400"/>
-          </a:xfrm>
-          <a:prstGeom prst="rect">
-            <a:avLst/>
-          </a:prstGeom>
-        </p:spPr>
-      </p:pic>
     </p:spTree>
   </p:cSld>
   <p:clrMapOvr>
@@ -3812,109 +4578,24 @@
       </p:grpSpPr>
       <p:sp>
         <p:nvSpPr>
-          <p:cNvPr id="2" name="Shape 0"/>
+          <p:cNvPr id="4" name="Text 2"/>
           <p:cNvSpPr/>
           <p:nvPr/>
         </p:nvSpPr>
         <p:spPr>
           <a:xfrm>
-            <a:off x="0" y="0"/>
-            <a:ext cx="18288000" cy="10287000"/>
+            <a:off x="1109960" y="1693664"/>
+            <a:ext cx="17638544" cy="440085"/>
           </a:xfrm>
           <a:prstGeom prst="rect">
             <a:avLst/>
           </a:prstGeom>
-          <a:gradFill rotWithShape="1">
-            <a:gsLst>
-              <a:gs pos="0">
-                <a:srgbClr val="2B2741">
-                  <a:alpha val="75000"/>
-                </a:srgbClr>
-              </a:gs>
-              <a:gs pos="58000">
-                <a:srgbClr val="2B2741">
-                  <a:alpha val="0"/>
-                </a:srgbClr>
-              </a:gs>
-            </a:gsLst>
-            <a:path path="circle">
-              <a:fillToRect l="80000" r="20000" b="100000"/>
-            </a:path>
-          </a:gradFill>
-          <a:ln/>
-        </p:spPr>
-        <p:txBody>
-          <a:bodyPr/>
-          <a:lstStyle/>
-          <a:p>
-            <a:endParaRPr lang="en-GB"/>
-          </a:p>
-        </p:txBody>
-      </p:sp>
-      <p:sp>
-        <p:nvSpPr>
-          <p:cNvPr id="3" name="Text 1"/>
-          <p:cNvSpPr/>
-          <p:nvPr/>
-        </p:nvSpPr>
-        <p:spPr>
-          <a:xfrm>
-            <a:off x="1143000" y="685651"/>
-            <a:ext cx="2019538" cy="190500"/>
-          </a:xfrm>
-          <a:prstGeom prst="rect">
-            <a:avLst/>
-          </a:prstGeom>
           <a:noFill/>
           <a:ln/>
         </p:spPr>
         <p:txBody>
           <a:bodyPr wrap="square" lIns="25400" tIns="25400" rIns="25400" bIns="25400" rtlCol="0" anchor="t">
-            <a:normAutofit/>
-          </a:bodyPr>
-          <a:lstStyle/>
-          <a:p>
-            <a:pPr marL="0" indent="0" algn="l">
-              <a:lnSpc>
-                <a:spcPct val="131154"/>
-              </a:lnSpc>
-              <a:buNone/>
-            </a:pPr>
-            <a:r>
-              <a:rPr lang="en-US" sz="1650" kern="0" spc="99" dirty="0">
-                <a:solidFill>
-                  <a:srgbClr val="9184D9"/>
-                </a:solidFill>
-                <a:latin typeface="Arial" pitchFamily="34" charset="0"/>
-                <a:ea typeface="Arial" pitchFamily="34" charset="-122"/>
-                <a:cs typeface="Arial" pitchFamily="34" charset="-120"/>
-              </a:rPr>
-              <a:t>TABLES &amp; INDEX</a:t>
-            </a:r>
-            <a:endParaRPr lang="en-US" sz="1650" dirty="0"/>
-          </a:p>
-        </p:txBody>
-      </p:sp>
-      <p:sp>
-        <p:nvSpPr>
-          <p:cNvPr id="4" name="Text 2"/>
-          <p:cNvSpPr/>
-          <p:nvPr/>
-        </p:nvSpPr>
-        <p:spPr>
-          <a:xfrm>
-            <a:off x="1109960" y="1693664"/>
-            <a:ext cx="17638544" cy="440085"/>
-          </a:xfrm>
-          <a:prstGeom prst="rect">
-            <a:avLst/>
-          </a:prstGeom>
-          <a:noFill/>
-          <a:ln/>
-        </p:spPr>
-        <p:txBody>
-          <a:bodyPr wrap="square" lIns="25400" tIns="25400" rIns="25400" bIns="25400" rtlCol="0" anchor="t">
-            <a:normAutofit/>
+            <a:normAutofit fontScale="70000" lnSpcReduction="20000"/>
           </a:bodyPr>
           <a:lstStyle/>
           <a:p>
@@ -3958,7 +4639,7 @@
         </p:spPr>
         <p:txBody>
           <a:bodyPr wrap="square" lIns="25400" tIns="25400" rIns="25400" bIns="25400" rtlCol="0" anchor="t">
-            <a:normAutofit/>
+            <a:normAutofit fontScale="70000" lnSpcReduction="20000"/>
           </a:bodyPr>
           <a:lstStyle/>
           <a:p>
@@ -4046,7 +4727,7 @@
         </p:spPr>
         <p:txBody>
           <a:bodyPr wrap="square" lIns="25400" tIns="25400" rIns="25400" bIns="25400" rtlCol="0" anchor="t">
-            <a:normAutofit/>
+            <a:normAutofit fontScale="70000" lnSpcReduction="20000"/>
           </a:bodyPr>
           <a:lstStyle/>
           <a:p>
@@ -4134,7 +4815,7 @@
         </p:spPr>
         <p:txBody>
           <a:bodyPr wrap="square" lIns="25400" tIns="25400" rIns="25400" bIns="25400" rtlCol="0" anchor="t">
-            <a:normAutofit/>
+            <a:normAutofit fontScale="70000" lnSpcReduction="20000"/>
           </a:bodyPr>
           <a:lstStyle/>
           <a:p>
@@ -4222,7 +4903,7 @@
         </p:spPr>
         <p:txBody>
           <a:bodyPr wrap="square" lIns="25400" tIns="25400" rIns="25400" bIns="25400" rtlCol="0" anchor="t">
-            <a:normAutofit/>
+            <a:normAutofit fontScale="70000" lnSpcReduction="20000"/>
           </a:bodyPr>
           <a:lstStyle/>
           <a:p>
@@ -4291,30 +4972,6 @@
           </a:p>
         </p:txBody>
       </p:sp>
-      <p:pic>
-        <p:nvPicPr>
-          <p:cNvPr id="13" name="Image 0" descr="preencoded.png"/>
-          <p:cNvPicPr>
-            <a:picLocks noChangeAspect="1"/>
-          </p:cNvPicPr>
-          <p:nvPr/>
-        </p:nvPicPr>
-        <p:blipFill>
-          <a:blip r:embed="rId3"/>
-          <a:stretch>
-            <a:fillRect/>
-          </a:stretch>
-        </p:blipFill>
-        <p:spPr>
-          <a:xfrm>
-            <a:off x="11167765" y="9867900"/>
-            <a:ext cx="5977235" cy="152400"/>
-          </a:xfrm>
-          <a:prstGeom prst="rect">
-            <a:avLst/>
-          </a:prstGeom>
-        </p:spPr>
-      </p:pic>
     </p:spTree>
   </p:cSld>
   <p:clrMapOvr>
@@ -4350,109 +5007,24 @@
       </p:grpSpPr>
       <p:sp>
         <p:nvSpPr>
-          <p:cNvPr id="2" name="Shape 0"/>
+          <p:cNvPr id="4" name="Text 2"/>
           <p:cNvSpPr/>
           <p:nvPr/>
         </p:nvSpPr>
         <p:spPr>
           <a:xfrm>
-            <a:off x="0" y="0"/>
-            <a:ext cx="18288000" cy="10287000"/>
+            <a:off x="1109960" y="1693664"/>
+            <a:ext cx="17638544" cy="440085"/>
           </a:xfrm>
           <a:prstGeom prst="rect">
             <a:avLst/>
           </a:prstGeom>
-          <a:gradFill rotWithShape="1">
-            <a:gsLst>
-              <a:gs pos="0">
-                <a:srgbClr val="2B2741">
-                  <a:alpha val="75000"/>
-                </a:srgbClr>
-              </a:gs>
-              <a:gs pos="58000">
-                <a:srgbClr val="2B2741">
-                  <a:alpha val="0"/>
-                </a:srgbClr>
-              </a:gs>
-            </a:gsLst>
-            <a:path path="circle">
-              <a:fillToRect l="80000" r="20000" b="100000"/>
-            </a:path>
-          </a:gradFill>
-          <a:ln/>
-        </p:spPr>
-        <p:txBody>
-          <a:bodyPr/>
-          <a:lstStyle/>
-          <a:p>
-            <a:endParaRPr lang="en-GB"/>
-          </a:p>
-        </p:txBody>
-      </p:sp>
-      <p:sp>
-        <p:nvSpPr>
-          <p:cNvPr id="3" name="Text 1"/>
-          <p:cNvSpPr/>
-          <p:nvPr/>
-        </p:nvSpPr>
-        <p:spPr>
-          <a:xfrm>
-            <a:off x="1143000" y="685651"/>
-            <a:ext cx="2297847" cy="190500"/>
-          </a:xfrm>
-          <a:prstGeom prst="rect">
-            <a:avLst/>
-          </a:prstGeom>
           <a:noFill/>
           <a:ln/>
         </p:spPr>
         <p:txBody>
           <a:bodyPr wrap="square" lIns="25400" tIns="25400" rIns="25400" bIns="25400" rtlCol="0" anchor="t">
-            <a:normAutofit/>
-          </a:bodyPr>
-          <a:lstStyle/>
-          <a:p>
-            <a:pPr marL="0" indent="0" algn="l">
-              <a:lnSpc>
-                <a:spcPct val="131154"/>
-              </a:lnSpc>
-              <a:buNone/>
-            </a:pPr>
-            <a:r>
-              <a:rPr lang="en-US" sz="1650" kern="0" spc="99" dirty="0">
-                <a:solidFill>
-                  <a:srgbClr val="9184D9"/>
-                </a:solidFill>
-                <a:latin typeface="Arial" pitchFamily="34" charset="0"/>
-                <a:ea typeface="Arial" pitchFamily="34" charset="-122"/>
-                <a:cs typeface="Arial" pitchFamily="34" charset="-120"/>
-              </a:rPr>
-              <a:t>DÉMO · FIL ROUGE</a:t>
-            </a:r>
-            <a:endParaRPr lang="en-US" sz="1650" dirty="0"/>
-          </a:p>
-        </p:txBody>
-      </p:sp>
-      <p:sp>
-        <p:nvSpPr>
-          <p:cNvPr id="4" name="Text 2"/>
-          <p:cNvSpPr/>
-          <p:nvPr/>
-        </p:nvSpPr>
-        <p:spPr>
-          <a:xfrm>
-            <a:off x="1109960" y="1693664"/>
-            <a:ext cx="17638544" cy="440085"/>
-          </a:xfrm>
-          <a:prstGeom prst="rect">
-            <a:avLst/>
-          </a:prstGeom>
-          <a:noFill/>
-          <a:ln/>
-        </p:spPr>
-        <p:txBody>
-          <a:bodyPr wrap="square" lIns="25400" tIns="25400" rIns="25400" bIns="25400" rtlCol="0" anchor="t">
-            <a:normAutofit/>
+            <a:normAutofit fontScale="70000" lnSpcReduction="20000"/>
           </a:bodyPr>
           <a:lstStyle/>
           <a:p>
@@ -4609,7 +5181,7 @@
         </p:spPr>
         <p:txBody>
           <a:bodyPr wrap="square" lIns="25400" tIns="25400" rIns="25400" bIns="25400" rtlCol="0" anchor="t">
-            <a:normAutofit/>
+            <a:normAutofit fontScale="92500" lnSpcReduction="10000"/>
           </a:bodyPr>
           <a:lstStyle/>
           <a:p>
@@ -4754,30 +5326,6 @@
           </a:p>
         </p:txBody>
       </p:sp>
-      <p:pic>
-        <p:nvPicPr>
-          <p:cNvPr id="8" name="Image 0" descr="preencoded.png"/>
-          <p:cNvPicPr>
-            <a:picLocks noChangeAspect="1"/>
-          </p:cNvPicPr>
-          <p:nvPr/>
-        </p:nvPicPr>
-        <p:blipFill>
-          <a:blip r:embed="rId3"/>
-          <a:stretch>
-            <a:fillRect/>
-          </a:stretch>
-        </p:blipFill>
-        <p:spPr>
-          <a:xfrm>
-            <a:off x="11167765" y="9867900"/>
-            <a:ext cx="5977235" cy="152400"/>
-          </a:xfrm>
-          <a:prstGeom prst="rect">
-            <a:avLst/>
-          </a:prstGeom>
-        </p:spPr>
-      </p:pic>
     </p:spTree>
   </p:cSld>
   <p:clrMapOvr>
@@ -4813,65 +5361,24 @@
       </p:grpSpPr>
       <p:sp>
         <p:nvSpPr>
-          <p:cNvPr id="2" name="Shape 0"/>
+          <p:cNvPr id="3" name="Text 1"/>
           <p:cNvSpPr/>
           <p:nvPr/>
         </p:nvSpPr>
         <p:spPr>
           <a:xfrm>
-            <a:off x="0" y="0"/>
-            <a:ext cx="18288000" cy="10287000"/>
+            <a:off x="1143000" y="685651"/>
+            <a:ext cx="630734" cy="190500"/>
           </a:xfrm>
           <a:prstGeom prst="rect">
             <a:avLst/>
           </a:prstGeom>
-          <a:gradFill rotWithShape="1">
-            <a:gsLst>
-              <a:gs pos="0">
-                <a:srgbClr val="2B2741">
-                  <a:alpha val="75000"/>
-                </a:srgbClr>
-              </a:gs>
-              <a:gs pos="58000">
-                <a:srgbClr val="2B2741">
-                  <a:alpha val="0"/>
-                </a:srgbClr>
-              </a:gs>
-            </a:gsLst>
-            <a:path path="circle">
-              <a:fillToRect l="80000" r="20000" b="100000"/>
-            </a:path>
-          </a:gradFill>
-          <a:ln/>
-        </p:spPr>
-        <p:txBody>
-          <a:bodyPr/>
-          <a:lstStyle/>
-          <a:p>
-            <a:endParaRPr lang="en-GB"/>
-          </a:p>
-        </p:txBody>
-      </p:sp>
-      <p:sp>
-        <p:nvSpPr>
-          <p:cNvPr id="3" name="Text 1"/>
-          <p:cNvSpPr/>
-          <p:nvPr/>
-        </p:nvSpPr>
-        <p:spPr>
-          <a:xfrm>
-            <a:off x="1143000" y="685651"/>
-            <a:ext cx="630734" cy="190500"/>
-          </a:xfrm>
-          <a:prstGeom prst="rect">
-            <a:avLst/>
-          </a:prstGeom>
           <a:noFill/>
           <a:ln/>
         </p:spPr>
         <p:txBody>
           <a:bodyPr wrap="square" lIns="25400" tIns="25400" rIns="25400" bIns="25400" rtlCol="0" anchor="t">
-            <a:normAutofit/>
+            <a:normAutofit fontScale="47500" lnSpcReduction="20000"/>
           </a:bodyPr>
           <a:lstStyle/>
           <a:p>
@@ -4915,7 +5422,7 @@
         </p:spPr>
         <p:txBody>
           <a:bodyPr wrap="square" lIns="25400" tIns="25400" rIns="25400" bIns="25400" rtlCol="0" anchor="t">
-            <a:normAutofit/>
+            <a:normAutofit fontScale="70000" lnSpcReduction="20000"/>
           </a:bodyPr>
           <a:lstStyle/>
           <a:p>
@@ -4959,7 +5466,7 @@
         </p:spPr>
         <p:txBody>
           <a:bodyPr wrap="square" lIns="25400" tIns="25400" rIns="25400" bIns="25400" rtlCol="0" anchor="t">
-            <a:normAutofit/>
+            <a:normAutofit lnSpcReduction="10000"/>
           </a:bodyPr>
           <a:lstStyle/>
           <a:p>
@@ -5289,30 +5796,6 @@
           </a:p>
         </p:txBody>
       </p:sp>
-      <p:pic>
-        <p:nvPicPr>
-          <p:cNvPr id="14" name="Image 0" descr="preencoded.png"/>
-          <p:cNvPicPr>
-            <a:picLocks noChangeAspect="1"/>
-          </p:cNvPicPr>
-          <p:nvPr/>
-        </p:nvPicPr>
-        <p:blipFill>
-          <a:blip r:embed="rId3"/>
-          <a:stretch>
-            <a:fillRect/>
-          </a:stretch>
-        </p:blipFill>
-        <p:spPr>
-          <a:xfrm>
-            <a:off x="11167765" y="9867900"/>
-            <a:ext cx="5977235" cy="152400"/>
-          </a:xfrm>
-          <a:prstGeom prst="rect">
-            <a:avLst/>
-          </a:prstGeom>
-        </p:spPr>
-      </p:pic>
     </p:spTree>
   </p:cSld>
   <p:clrMapOvr>
@@ -5348,109 +5831,24 @@
       </p:grpSpPr>
       <p:sp>
         <p:nvSpPr>
-          <p:cNvPr id="2" name="Shape 0"/>
+          <p:cNvPr id="4" name="Text 2"/>
           <p:cNvSpPr/>
           <p:nvPr/>
         </p:nvSpPr>
         <p:spPr>
           <a:xfrm>
-            <a:off x="0" y="0"/>
-            <a:ext cx="18288000" cy="10287000"/>
+            <a:off x="1109960" y="1693664"/>
+            <a:ext cx="17638544" cy="440085"/>
           </a:xfrm>
           <a:prstGeom prst="rect">
             <a:avLst/>
           </a:prstGeom>
-          <a:gradFill rotWithShape="1">
-            <a:gsLst>
-              <a:gs pos="0">
-                <a:srgbClr val="2B2741">
-                  <a:alpha val="75000"/>
-                </a:srgbClr>
-              </a:gs>
-              <a:gs pos="58000">
-                <a:srgbClr val="2B2741">
-                  <a:alpha val="0"/>
-                </a:srgbClr>
-              </a:gs>
-            </a:gsLst>
-            <a:path path="circle">
-              <a:fillToRect l="80000" r="20000" b="100000"/>
-            </a:path>
-          </a:gradFill>
-          <a:ln/>
-        </p:spPr>
-        <p:txBody>
-          <a:bodyPr/>
-          <a:lstStyle/>
-          <a:p>
-            <a:endParaRPr lang="en-GB"/>
-          </a:p>
-        </p:txBody>
-      </p:sp>
-      <p:sp>
-        <p:nvSpPr>
-          <p:cNvPr id="3" name="Text 1"/>
-          <p:cNvSpPr/>
-          <p:nvPr/>
-        </p:nvSpPr>
-        <p:spPr>
-          <a:xfrm>
-            <a:off x="1143000" y="685651"/>
-            <a:ext cx="1935718" cy="190500"/>
-          </a:xfrm>
-          <a:prstGeom prst="rect">
-            <a:avLst/>
-          </a:prstGeom>
           <a:noFill/>
           <a:ln/>
         </p:spPr>
         <p:txBody>
           <a:bodyPr wrap="square" lIns="25400" tIns="25400" rIns="25400" bIns="25400" rtlCol="0" anchor="t">
-            <a:normAutofit/>
-          </a:bodyPr>
-          <a:lstStyle/>
-          <a:p>
-            <a:pPr marL="0" indent="0" algn="l">
-              <a:lnSpc>
-                <a:spcPct val="131154"/>
-              </a:lnSpc>
-              <a:buNone/>
-            </a:pPr>
-            <a:r>
-              <a:rPr lang="en-US" sz="1650" kern="0" spc="99" dirty="0">
-                <a:solidFill>
-                  <a:srgbClr val="9184D9"/>
-                </a:solidFill>
-                <a:latin typeface="Arial" pitchFamily="34" charset="0"/>
-                <a:ea typeface="Arial" pitchFamily="34" charset="-122"/>
-                <a:cs typeface="Arial" pitchFamily="34" charset="-120"/>
-              </a:rPr>
-              <a:t>RÉCAPITULATIF</a:t>
-            </a:r>
-            <a:endParaRPr lang="en-US" sz="1650" dirty="0"/>
-          </a:p>
-        </p:txBody>
-      </p:sp>
-      <p:sp>
-        <p:nvSpPr>
-          <p:cNvPr id="4" name="Text 2"/>
-          <p:cNvSpPr/>
-          <p:nvPr/>
-        </p:nvSpPr>
-        <p:spPr>
-          <a:xfrm>
-            <a:off x="1109960" y="1693664"/>
-            <a:ext cx="17638544" cy="440085"/>
-          </a:xfrm>
-          <a:prstGeom prst="rect">
-            <a:avLst/>
-          </a:prstGeom>
-          <a:noFill/>
-          <a:ln/>
-        </p:spPr>
-        <p:txBody>
-          <a:bodyPr wrap="square" lIns="25400" tIns="25400" rIns="25400" bIns="25400" rtlCol="0" anchor="t">
-            <a:normAutofit/>
+            <a:normAutofit fontScale="70000" lnSpcReduction="20000"/>
           </a:bodyPr>
           <a:lstStyle/>
           <a:p>
@@ -5579,30 +5977,6 @@
           </a:p>
         </p:txBody>
       </p:sp>
-      <p:pic>
-        <p:nvPicPr>
-          <p:cNvPr id="6" name="Image 0" descr="preencoded.png"/>
-          <p:cNvPicPr>
-            <a:picLocks noChangeAspect="1"/>
-          </p:cNvPicPr>
-          <p:nvPr/>
-        </p:nvPicPr>
-        <p:blipFill>
-          <a:blip r:embed="rId3"/>
-          <a:stretch>
-            <a:fillRect/>
-          </a:stretch>
-        </p:blipFill>
-        <p:spPr>
-          <a:xfrm>
-            <a:off x="11167765" y="9867900"/>
-            <a:ext cx="5977235" cy="152400"/>
-          </a:xfrm>
-          <a:prstGeom prst="rect">
-            <a:avLst/>
-          </a:prstGeom>
-        </p:spPr>
-      </p:pic>
     </p:spTree>
   </p:cSld>
   <p:clrMapOvr>
@@ -5638,47 +6012,6 @@
       </p:grpSpPr>
       <p:sp>
         <p:nvSpPr>
-          <p:cNvPr id="2" name="Shape 0"/>
-          <p:cNvSpPr/>
-          <p:nvPr/>
-        </p:nvSpPr>
-        <p:spPr>
-          <a:xfrm>
-            <a:off x="0" y="0"/>
-            <a:ext cx="18288000" cy="10287000"/>
-          </a:xfrm>
-          <a:prstGeom prst="rect">
-            <a:avLst/>
-          </a:prstGeom>
-          <a:gradFill rotWithShape="1">
-            <a:gsLst>
-              <a:gs pos="0">
-                <a:srgbClr val="353A80">
-                  <a:alpha val="70000"/>
-                </a:srgbClr>
-              </a:gs>
-              <a:gs pos="64000">
-                <a:srgbClr val="353A80">
-                  <a:alpha val="0"/>
-                </a:srgbClr>
-              </a:gs>
-            </a:gsLst>
-            <a:path path="circle">
-              <a:fillToRect l="22000" t="42000" r="78000" b="58000"/>
-            </a:path>
-          </a:gradFill>
-          <a:ln/>
-        </p:spPr>
-        <p:txBody>
-          <a:bodyPr/>
-          <a:lstStyle/>
-          <a:p>
-            <a:endParaRPr lang="en-GB"/>
-          </a:p>
-        </p:txBody>
-      </p:sp>
-      <p:sp>
-        <p:nvSpPr>
           <p:cNvPr id="3" name="Text 1"/>
           <p:cNvSpPr/>
           <p:nvPr/>
@@ -5740,7 +6073,7 @@
         </p:spPr>
         <p:txBody>
           <a:bodyPr wrap="square" lIns="25400" tIns="25400" rIns="25400" bIns="25400" rtlCol="0" anchor="t">
-            <a:normAutofit/>
+            <a:normAutofit fontScale="70000" lnSpcReduction="20000"/>
           </a:bodyPr>
           <a:lstStyle/>
           <a:p>
@@ -6428,15 +6761,6 @@
 </file>
 
 <file path=customXml/item1.xml><?xml version="1.0" encoding="utf-8"?>
-<?mso-contentType ?>
-<FormTemplates xmlns="http://schemas.microsoft.com/sharepoint/v3/contenttype/forms">
-  <Display>DocumentLibraryForm</Display>
-  <Edit>DocumentLibraryForm</Edit>
-  <New>DocumentLibraryForm</New>
-</FormTemplates>
-</file>
-
-<file path=customXml/item2.xml><?xml version="1.0" encoding="utf-8"?>
 <p:properties xmlns:p="http://schemas.microsoft.com/office/2006/metadata/properties" xmlns:xsi="http://www.w3.org/2001/XMLSchema-instance" xmlns:pc="http://schemas.microsoft.com/office/infopath/2007/PartnerControls">
   <documentManagement>
     <TaxCatchAll xmlns="33363a87-7e43-46da-9332-4c6d176b06e4" xsi:nil="true"/>
@@ -6447,7 +6771,7 @@
 </p:properties>
 </file>
 
-<file path=customXml/item3.xml><?xml version="1.0" encoding="utf-8"?>
+<file path=customXml/item2.xml><?xml version="1.0" encoding="utf-8"?>
 <ct:contentTypeSchema xmlns:ct="http://schemas.microsoft.com/office/2006/metadata/contentType" xmlns:ma="http://schemas.microsoft.com/office/2006/metadata/properties/metaAttributes" ct:_="" ma:_="" ma:contentTypeName="Document" ma:contentTypeID="0x0101000085964E25350F4FB3FE643AE11B2B20" ma:contentTypeVersion="10" ma:contentTypeDescription="Create a new document." ma:contentTypeScope="" ma:versionID="1e1d1b9c64e4e863bf8aa3867e361155">
   <xsd:schema xmlns:xsd="http://www.w3.org/2001/XMLSchema" xmlns:xs="http://www.w3.org/2001/XMLSchema" xmlns:p="http://schemas.microsoft.com/office/2006/metadata/properties" xmlns:ns2="d9df9240-fc95-4deb-9c9d-de700c44a7a7" xmlns:ns3="33363a87-7e43-46da-9332-4c6d176b06e4" targetNamespace="http://schemas.microsoft.com/office/2006/metadata/properties" ma:root="true" ma:fieldsID="6f44e94be1ec4ee84c894018ce3c7098" ns2:_="" ns3:_="">
     <xsd:import namespace="d9df9240-fc95-4deb-9c9d-de700c44a7a7"/>
@@ -6636,15 +6960,16 @@
 </ct:contentTypeSchema>
 </file>
 
-<file path=customXml/itemProps1.xml><?xml version="1.0" encoding="utf-8"?>
-<ds:datastoreItem xmlns:ds="http://schemas.openxmlformats.org/officeDocument/2006/customXml" ds:itemID="{0BDEB156-3EF4-48F8-9E38-04770E6CA297}">
-  <ds:schemaRefs>
-    <ds:schemaRef ds:uri="http://schemas.microsoft.com/sharepoint/v3/contenttype/forms"/>
-  </ds:schemaRefs>
-</ds:datastoreItem>
+<file path=customXml/item3.xml><?xml version="1.0" encoding="utf-8"?>
+<?mso-contentType ?>
+<FormTemplates xmlns="http://schemas.microsoft.com/sharepoint/v3/contenttype/forms">
+  <Display>DocumentLibraryForm</Display>
+  <Edit>DocumentLibraryForm</Edit>
+  <New>DocumentLibraryForm</New>
+</FormTemplates>
 </file>
 
-<file path=customXml/itemProps2.xml><?xml version="1.0" encoding="utf-8"?>
+<file path=customXml/itemProps1.xml><?xml version="1.0" encoding="utf-8"?>
 <ds:datastoreItem xmlns:ds="http://schemas.openxmlformats.org/officeDocument/2006/customXml" ds:itemID="{BE5AE6CD-266F-4506-9484-5C19F817C7DE}">
   <ds:schemaRefs>
     <ds:schemaRef ds:uri="http://purl.org/dc/dcmitype/"/>
@@ -6661,8 +6986,16 @@
 </ds:datastoreItem>
 </file>
 
+<file path=customXml/itemProps2.xml><?xml version="1.0" encoding="utf-8"?>
+<ds:datastoreItem xmlns:ds="http://schemas.openxmlformats.org/officeDocument/2006/customXml" ds:itemID="{D98F966C-75B3-4C73-BFA5-AA6111EACCBE}"/>
+</file>
+
 <file path=customXml/itemProps3.xml><?xml version="1.0" encoding="utf-8"?>
-<ds:datastoreItem xmlns:ds="http://schemas.openxmlformats.org/officeDocument/2006/customXml" ds:itemID="{59E49AC9-BBE0-4EBE-A36A-A7CB7AF59BA4}"/>
+<ds:datastoreItem xmlns:ds="http://schemas.openxmlformats.org/officeDocument/2006/customXml" ds:itemID="{0BDEB156-3EF4-48F8-9E38-04770E6CA297}">
+  <ds:schemaRefs>
+    <ds:schemaRef ds:uri="http://schemas.microsoft.com/sharepoint/v3/contenttype/forms"/>
+  </ds:schemaRefs>
+</ds:datastoreItem>
 </file>
 
 <file path=docMetadata/LabelInfo.xml><?xml version="1.0" encoding="utf-8"?>

</xml_diff>